<commit_message>
TL02 Vollausbau: Sec 2/3/6 gesynct, Reifegrad-Matrix, Artefakte
- content/modules/TL02.md: Sec 2/3/6 gesynct, ergaenzung: true,
  Lernziel-Formulierung "coachen/trainieren" angeglichen
- Reifegrad-Matrix SVG (situatives Fuehren) + GRAFIKEN_MAP-Eintrag
- Trainerhandbuch-PDF, Teilnehmer-PDF, Praesentation-PPTX neu generiert

Co-Authored-By: Claude Opus 4.8 <noreply@anthropic.com>
</commit_message>
<xml_diff>
--- a/protected-downloads/praesentation/TL02.pptx
+++ b/protected-downloads/praesentation/TL02.pptx
@@ -15,6 +15,8 @@
     <p:sldId id="263" r:id="rId15"/>
     <p:sldId id="264" r:id="rId16"/>
     <p:sldId id="265" r:id="rId17"/>
+    <p:sldId id="266" r:id="rId18"/>
+    <p:sldId id="267" r:id="rId19"/>
   </p:sldIdLst>
   <p:sldSz cx="12188952" cy="6858000" type="screen4x3"/>
   <p:notesSz cx="6858000" cy="9144000"/>
@@ -511,7 +513,7 @@
           <a:lstStyle/>
           <a:p>
             <a:r>
-              <a:t>Siehe Trainerhandbuch (Sektion 3) für Moderationshinweise, Timing und erwartete Teilnehmerreaktionen.</a:t>
+              <a:t>Agenda aus dem Ablaufplan (Sektion 3.1). Timing und Pausen siehe Trainerhandbuch.</a:t>
             </a:r>
           </a:p>
         </p:txBody>
@@ -581,12 +583,7 @@
           <a:lstStyle/>
           <a:p>
             <a:r>
-              <a:t>Trainer-Hinweis: Das situative Modell diagnostiziert Sigrids Zurückhaltung als D3 (hohe Kompetenz, sinkendes Engagement). Das greift, wenn die Ursache Selbstzweifel oder Komfortzonenverlust ist. Wenn Sigrid das Tool jedoch aus einer grundsätzlichen Überzeugung ablehnt – sie hält maschinelle Ratings prinzipiell für fachlich minderwertig – dann liegt kein D3-Problem vor, sondern ein Wertekonflikt. Das situative Modell trennt Kompetenz und Commitment, nicht Kompetenz und Wertekongruenz. Ein Berater, der eine Vorgabe aus Überzeugung ablehnt, braucht kein anderes S3/S4-Führungsverhalten, sondern ein klärendes Gespräch über Erwartungen und Verbindlichkeiten. Diese Grenze des Modells ist für den Seminarkontext wichtig: Führungsstile lösen keine Wertekonflikte – sie strukturieren die Beziehungsqualität.</a:t>
-            </a:r>
-          </a:p>
-          <a:p>
-            <a:r>
-              <a:t>Trainer-Hinweis: Die Sequenz Vereinbarung → Nicht-Einhalten → Konsequenz ist der häufigste Punkt, an dem neue Teamleiter ausweichen – sie führen lieber ein drittes Erklärungsgespräch, als die Nicht-Erfüllung direkt zu benennen. Das kostet Glaubwürdigkeit. Die entscheidende Faustregel: Sobald eine Vereinbarung nicht eingehalten wurde, ändert sich der Gesprächstyp. Es ist dann kein S3-Gespräch mehr, sondern ein Klärungsgespräch mit Konsequenzklarheit. Dieses Format wird in TL05 (Feedbackgespräche) und TL06 (schwierige Gespräche) vertieft.</a:t>
+              <a:t>Siehe Trainerhandbuch (Sektion 3) für Moderationshinweise, Timing und erwartete Teilnehmerreaktionen.</a:t>
             </a:r>
           </a:p>
         </p:txBody>
@@ -656,7 +653,12 @@
           <a:lstStyle/>
           <a:p>
             <a:r>
-              <a:t>Trainer-Hinweis: Der Sprachcheck ist kein Bewertungsformat, sondern ein Kalibrierungsformat. Ziel ist, dass Teilnehmer die Wirkung ihrer Formulierungen aus der Empfängerperspektive einschätzen können – ohne zu simulieren. Häufige Beobachtung: Einstiege sind entweder zu weich (Entschuldigung für das Gespräch) oder zu scharf (Vorwurfscharakter). Der richtige Ton ist: neutral, sachlich, erwartungsklar.</a:t>
+              <a:t>Trainer-Hinweis: Das situative Modell diagnostiziert Sigrids Zurückhaltung als D3 (hohe Kompetenz, sinkendes Engagement). Das greift, wenn die Ursache Selbstzweifel oder Komfortzonenverlust ist. Wenn Sigrid das Tool jedoch aus einer grundsätzlichen Überzeugung ablehnt – sie hält maschinelle Ratings prinzipiell für fachlich minderwertig – dann liegt kein D3-Problem vor, sondern ein Wertekonflikt. Das situative Modell trennt Kompetenz und Commitment, nicht Kompetenz und Wertekongruenz. Ein Berater, der eine Vorgabe aus Überzeugung ablehnt, braucht kein anderes S3/S4-Führungsverhalten, sondern ein klärendes Gespräch über Erwartungen und Verbindlichkeiten. Diese Grenze des Modells ist für den Seminarkontext wichtig: Führungsstile lösen keine Wertekonflikte – sie strukturieren die Beziehungsqualität.</a:t>
+            </a:r>
+          </a:p>
+          <a:p>
+            <a:r>
+              <a:t>Trainer-Hinweis: Die Sequenz Vereinbarung → Nicht-Einhalten → Konsequenz ist der häufigste Punkt, an dem neue Teamleiter ausweichen – sie führen lieber ein drittes Erklärungsgespräch, als die Nicht-Erfüllung direkt zu benennen. Das kostet Glaubwürdigkeit. Die entscheidende Faustregel: Sobald eine Vereinbarung nicht eingehalten wurde, ändert sich der Gesprächstyp. Es ist dann kein S3-Gespräch mehr, sondern ein Klärungsgespräch mit Konsequenzklarheit. Dieses Format wird in TL05 (Feedbackgespräche) und TL06 (schwierige Gespräche) vertieft.</a:t>
             </a:r>
           </a:p>
         </p:txBody>
@@ -726,47 +728,7 @@
           <a:lstStyle/>
           <a:p>
             <a:r>
-              <a:t>Trainer-Hinweis: Keine Sammlung im Plenum – die Selbstreflexion bleibt persönlich. Sie dient als Einstieg in die kollegiale Fallberatung: Die Frage 4 kann freiwillig als Ausgangsfall eingebracht werden.</a:t>
-            </a:r>
-          </a:p>
-          <a:p>
-            <a:r>
-              <a:t>AB-1 Musterlösung (Trainer-Version)</a:t>
-            </a:r>
-          </a:p>
-          <a:p>
-            <a:r>
-              <a:t>Ausfüllbeispiel (Orientierung für den Trainer, wird nicht ausgeteilt)</a:t>
-            </a:r>
-          </a:p>
-          <a:p>
-            <a:r>
-              <a:t>Mitarbeiter: Jonas W. | Aufgabe: Erste eigenständige Kreditunterlagenprüfung</a:t>
-            </a:r>
-          </a:p>
-          <a:p>
-            <a:r>
-              <a:t>Reifegrad: D1 | Führungsstil: S1 (Dirigieren)</a:t>
-            </a:r>
-          </a:p>
-          <a:p>
-            <a:r>
-              <a:t>Konkretes Verhalten: Schritt-für-Schritt-Checkliste, tägl. 10-Minuten-Check, wenig Diskussion, viel Struktur.</a:t>
-            </a:r>
-          </a:p>
-          <a:p>
-            <a:r>
-              <a:t>Bisheriger Stil: oft spontan S2 (erklärt viel, geht auf Fragen ein) – kostet Zeit und verwirrt Jonas, da er noch keine Basis hat, auf der er die Erklärungen einordnen kann.</a:t>
-            </a:r>
-          </a:p>
-          <a:p>
-            <a:r>
-              <a:t>Trainer-Hinweis: Häufige Fehlerquelle: Engagement (Jonas fragt viel, ist sichtbar motiviert) wird mit hohem Reifegrad verwechselt. Das Modell trennt Können und Wollen bewusst – Jonas hat viel Wollen (D1) und braucht deshalb keine Partizipation, sondern Struktur. Hohe Sichtbarkeit (fragt viel, ist enthusiastisch) ist kein Reifegrad-Merkmal – es ist ein Engagement-Merkmal.</a:t>
-            </a:r>
-          </a:p>
-          <a:p>
-            <a:r>
-              <a:t>Trainer-Hinweis: Die Formulierungsbausteine decken S1, S4 und S2/S3 ab. Die TN sollen den passenden für ihre eigene Situation wählen und ggf. eigene Formulierungen entwickeln. Kein Richtig/Falsch, sondern Sprachfähigkeit für Stilentscheidungen aufbauen.</a:t>
+              <a:t>Trainer-Hinweis: Der Sprachcheck ist kein Bewertungsformat, sondern ein Kalibrierungsformat. Ziel ist, dass Teilnehmer die Wirkung ihrer Formulierungen aus der Empfängerperspektive einschätzen können – ohne zu simulieren. Häufige Beobachtung: Einstiege sind entweder zu weich (Entschuldigung für das Gespräch) oder zu scharf (Vorwurfscharakter). Der richtige Ton ist: neutral, sachlich, erwartungsklar.</a:t>
             </a:r>
           </a:p>
         </p:txBody>
@@ -836,7 +798,47 @@
           <a:lstStyle/>
           <a:p>
             <a:r>
-              <a:t>Siehe Trainerhandbuch (Sektion 3) für Moderationshinweise, Timing und erwartete Teilnehmerreaktionen.</a:t>
+              <a:t>Trainer-Hinweis: Keine Sammlung im Plenum – die Selbstreflexion bleibt persönlich. Sie dient als Einstieg in die kollegiale Fallberatung: Die Frage 4 kann freiwillig als Ausgangsfall eingebracht werden.</a:t>
+            </a:r>
+          </a:p>
+          <a:p>
+            <a:r>
+              <a:t>AB-1 Musterlösung (Trainer-Version)</a:t>
+            </a:r>
+          </a:p>
+          <a:p>
+            <a:r>
+              <a:t>Ausfüllbeispiel (Orientierung für den Trainer, wird nicht ausgeteilt)</a:t>
+            </a:r>
+          </a:p>
+          <a:p>
+            <a:r>
+              <a:t>Mitarbeiter: Jonas W. | Aufgabe: Erste eigenständige Kreditunterlagenprüfung</a:t>
+            </a:r>
+          </a:p>
+          <a:p>
+            <a:r>
+              <a:t>Reifegrad: D1 | Führungsstil: S1 (Dirigieren)</a:t>
+            </a:r>
+          </a:p>
+          <a:p>
+            <a:r>
+              <a:t>Konkretes Verhalten: Schritt-für-Schritt-Checkliste, tägl. 10-Minuten-Check, wenig Diskussion, viel Struktur.</a:t>
+            </a:r>
+          </a:p>
+          <a:p>
+            <a:r>
+              <a:t>Bisheriger Stil: oft spontan S2 (erklärt viel, geht auf Fragen ein) – kostet Zeit und verwirrt Jonas, da er noch keine Basis hat, auf der er die Erklärungen einordnen kann.</a:t>
+            </a:r>
+          </a:p>
+          <a:p>
+            <a:r>
+              <a:t>Trainer-Hinweis: Häufige Fehlerquelle: Engagement (Jonas fragt viel, ist sichtbar motiviert) wird mit hohem Reifegrad verwechselt. Das Modell trennt Können und Wollen bewusst – Jonas hat viel Wollen (D1) und braucht deshalb keine Partizipation, sondern Struktur. Hohe Sichtbarkeit (fragt viel, ist enthusiastisch) ist kein Reifegrad-Merkmal – es ist ein Engagement-Merkmal.</a:t>
+            </a:r>
+          </a:p>
+          <a:p>
+            <a:r>
+              <a:t>Trainer-Hinweis: Die Formulierungsbausteine decken S1, S4 und S2/S3 ab. Die TN sollen den passenden für ihre eigene Situation wählen und ggf. eigene Formulierungen entwickeln. Kein Richtig/Falsch, sondern Sprachfähigkeit für Stilentscheidungen aufbauen.</a:t>
             </a:r>
           </a:p>
         </p:txBody>
@@ -932,6 +934,76 @@
 </file>
 
 <file path=ppt/notesSlides/notesSlide7.xml><?xml version="1.0" encoding="utf-8"?>
+<p:notes xmlns:a="http://schemas.openxmlformats.org/drawingml/2006/main" xmlns:p="http://schemas.openxmlformats.org/presentationml/2006/main" xmlns:r="http://schemas.openxmlformats.org/officeDocument/2006/relationships">
+  <p:cSld>
+    <p:spTree>
+      <p:nvGrpSpPr>
+        <p:cNvPr id="1" name=""/>
+        <p:cNvGrpSpPr/>
+        <p:nvPr/>
+      </p:nvGrpSpPr>
+      <p:grpSpPr>
+        <a:xfrm>
+          <a:off x="0" y="0"/>
+          <a:ext cx="0" cy="0"/>
+          <a:chOff x="0" y="0"/>
+          <a:chExt cx="0" cy="0"/>
+        </a:xfrm>
+      </p:grpSpPr>
+      <p:sp>
+        <p:nvSpPr>
+          <p:cNvPr id="2" name="Slide Image Placeholder 1"/>
+          <p:cNvSpPr>
+            <a:spLocks noGrp="1"/>
+          </p:cNvSpPr>
+          <p:nvPr>
+            <p:ph type="sldImg" idx="2"/>
+          </p:nvPr>
+        </p:nvSpPr>
+        <p:spPr/>
+      </p:sp>
+      <p:sp>
+        <p:nvSpPr>
+          <p:cNvPr id="3" name="Notes Placeholder 2"/>
+          <p:cNvSpPr>
+            <a:spLocks noGrp="1"/>
+          </p:cNvSpPr>
+          <p:nvPr>
+            <p:ph type="body" idx="3" sz="quarter"/>
+          </p:nvPr>
+        </p:nvSpPr>
+        <p:spPr/>
+        <p:txBody>
+          <a:bodyPr/>
+          <a:lstStyle/>
+          <a:p>
+            <a:r>
+              <a:t>Siehe Trainerhandbuch (Sektion 3) für Moderationshinweise, Timing und erwartete Teilnehmerreaktionen.</a:t>
+            </a:r>
+          </a:p>
+        </p:txBody>
+      </p:sp>
+      <p:sp>
+        <p:nvSpPr>
+          <p:cNvPr id="4" name="Slide Number Placeholder 3"/>
+          <p:cNvSpPr>
+            <a:spLocks noGrp="1"/>
+          </p:cNvSpPr>
+          <p:nvPr>
+            <p:ph type="sldNum" idx="5" sz="quarter"/>
+          </p:nvPr>
+        </p:nvSpPr>
+        <p:spPr/>
+      </p:sp>
+    </p:spTree>
+  </p:cSld>
+  <p:clrMapOvr>
+    <a:masterClrMapping/>
+  </p:clrMapOvr>
+</p:notes>
+</file>
+
+<file path=ppt/notesSlides/notesSlide8.xml><?xml version="1.0" encoding="utf-8"?>
 <p:notes xmlns:a="http://schemas.openxmlformats.org/drawingml/2006/main" xmlns:p="http://schemas.openxmlformats.org/presentationml/2006/main" xmlns:r="http://schemas.openxmlformats.org/officeDocument/2006/relationships">
   <p:cSld>
     <p:spTree>
@@ -4794,6 +4866,1184 @@
                 </a:solidFill>
                 <a:latin typeface="Arial"/>
               </a:rPr>
+              <a:t>Stil- und Merkkarte: Situatives Führen auf einen Blick</a:t>
+            </a:r>
+          </a:p>
+        </p:txBody>
+      </p:sp>
+      <p:sp>
+        <p:nvSpPr>
+          <p:cNvPr id="8" name="TextBox 7"/>
+          <p:cNvSpPr txBox="1"/>
+          <p:nvPr/>
+        </p:nvSpPr>
+        <p:spPr>
+          <a:xfrm>
+            <a:off x="685800" y="1417320"/>
+            <a:ext cx="10817352" cy="4892040"/>
+          </a:xfrm>
+          <a:prstGeom prst="rect">
+            <a:avLst/>
+          </a:prstGeom>
+          <a:noFill/>
+        </p:spPr>
+        <p:txBody>
+          <a:bodyPr wrap="square">
+            <a:spAutoFit/>
+          </a:bodyPr>
+          <a:lstStyle/>
+          <a:p>
+            <a:pPr>
+              <a:spcBef>
+                <a:spcPts val="400"/>
+              </a:spcBef>
+              <a:spcAft>
+                <a:spcPts val="200"/>
+              </a:spcAft>
+            </a:pPr>
+            <a:r>
+              <a:rPr sz="1200">
+                <a:solidFill>
+                  <a:srgbClr val="3D5466"/>
+                </a:solidFill>
+                <a:latin typeface="Arial"/>
+              </a:rPr>
+              <a:t>Die vier Führungsstile nach Hersey &amp; Blanchard (1996)</a:t>
+            </a:r>
+          </a:p>
+          <a:p>
+            <a:pPr>
+              <a:spcBef>
+                <a:spcPts val="400"/>
+              </a:spcBef>
+              <a:spcAft>
+                <a:spcPts val="200"/>
+              </a:spcAft>
+            </a:pPr>
+            <a:r>
+              <a:rPr sz="1200">
+                <a:solidFill>
+                  <a:srgbClr val="3D5466"/>
+                </a:solidFill>
+                <a:latin typeface="Arial"/>
+              </a:rPr>
+              <a:t>Der Diagnosepfad:</a:t>
+            </a:r>
+          </a:p>
+          <a:p>
+            <a:pPr marL="190500" indent="-190500">
+              <a:spcBef>
+                <a:spcPts val="400"/>
+              </a:spcBef>
+              <a:spcAft>
+                <a:spcPts val="200"/>
+              </a:spcAft>
+            </a:pPr>
+            <a:r>
+              <a:rPr sz="1300">
+                <a:solidFill>
+                  <a:srgbClr val="3D5466"/>
+                </a:solidFill>
+                <a:latin typeface="Arial"/>
+              </a:rPr>
+              <a:t>▸  Aufgabe benennen – Reifegrad ist immer aufgabenbezogen, nicht personenbezogen</a:t>
+            </a:r>
+          </a:p>
+          <a:p>
+            <a:pPr marL="190500" indent="-190500">
+              <a:spcBef>
+                <a:spcPts val="400"/>
+              </a:spcBef>
+              <a:spcAft>
+                <a:spcPts val="200"/>
+              </a:spcAft>
+            </a:pPr>
+            <a:r>
+              <a:rPr sz="1300">
+                <a:solidFill>
+                  <a:srgbClr val="3D5466"/>
+                </a:solidFill>
+                <a:latin typeface="Arial"/>
+              </a:rPr>
+              <a:t>▸  Kompetenz einschätzen – Kann er/sie das? (Können, Wissen, Erfahrung für genau dies)</a:t>
+            </a:r>
+          </a:p>
+          <a:p>
+            <a:pPr marL="190500" indent="-190500">
+              <a:spcBef>
+                <a:spcPts val="400"/>
+              </a:spcBef>
+              <a:spcAft>
+                <a:spcPts val="200"/>
+              </a:spcAft>
+            </a:pPr>
+            <a:r>
+              <a:rPr sz="1300">
+                <a:solidFill>
+                  <a:srgbClr val="3D5466"/>
+                </a:solidFill>
+                <a:latin typeface="Arial"/>
+              </a:rPr>
+              <a:t>▸  Engagement einschätzen – Will er/sie das? (Motivation, Selbstvertrauen, Bereitschaft)</a:t>
+            </a:r>
+          </a:p>
+          <a:p>
+            <a:pPr marL="190500" indent="-190500">
+              <a:spcBef>
+                <a:spcPts val="400"/>
+              </a:spcBef>
+              <a:spcAft>
+                <a:spcPts val="200"/>
+              </a:spcAft>
+            </a:pPr>
+            <a:r>
+              <a:rPr sz="1300">
+                <a:solidFill>
+                  <a:srgbClr val="3D5466"/>
+                </a:solidFill>
+                <a:latin typeface="Arial"/>
+              </a:rPr>
+              <a:t>▸  Reifegrad bestimmen (D1–D4)</a:t>
+            </a:r>
+          </a:p>
+          <a:p>
+            <a:pPr marL="190500" indent="-190500">
+              <a:spcBef>
+                <a:spcPts val="400"/>
+              </a:spcBef>
+              <a:spcAft>
+                <a:spcPts val="200"/>
+              </a:spcAft>
+            </a:pPr>
+            <a:r>
+              <a:rPr sz="1300">
+                <a:solidFill>
+                  <a:srgbClr val="3D5466"/>
+                </a:solidFill>
+                <a:latin typeface="Arial"/>
+              </a:rPr>
+              <a:t>▸  Stil ableiten (S1–S4) und im Gespräch zeigen</a:t>
+            </a:r>
+          </a:p>
+          <a:p>
+            <a:pPr>
+              <a:spcBef>
+                <a:spcPts val="400"/>
+              </a:spcBef>
+              <a:spcAft>
+                <a:spcPts val="200"/>
+              </a:spcAft>
+            </a:pPr>
+            <a:r>
+              <a:rPr sz="1200">
+                <a:solidFill>
+                  <a:srgbClr val="3D5466"/>
+                </a:solidFill>
+                <a:latin typeface="Arial"/>
+              </a:rPr>
+              <a:t>Warnsignale für Stil-Mismatch:</a:t>
+            </a:r>
+          </a:p>
+          <a:p>
+            <a:pPr marL="190500" indent="-190500">
+              <a:spcBef>
+                <a:spcPts val="400"/>
+              </a:spcBef>
+              <a:spcAft>
+                <a:spcPts val="200"/>
+              </a:spcAft>
+            </a:pPr>
+            <a:r>
+              <a:rPr sz="1300">
+                <a:solidFill>
+                  <a:srgbClr val="3D5466"/>
+                </a:solidFill>
+                <a:latin typeface="Arial"/>
+              </a:rPr>
+              <a:t>▸  Engagierter Mitarbeiter wird zunehmend passiv → Überführungsgefahr (zu viel S1 bei steigendem Reifegrad)</a:t>
+            </a:r>
+          </a:p>
+          <a:p>
+            <a:pPr marL="190500" indent="-190500">
+              <a:spcBef>
+                <a:spcPts val="400"/>
+              </a:spcBef>
+              <a:spcAft>
+                <a:spcPts val="200"/>
+              </a:spcAft>
+            </a:pPr>
+            <a:r>
+              <a:rPr sz="1300">
+                <a:solidFill>
+                  <a:srgbClr val="3D5466"/>
+                </a:solidFill>
+                <a:latin typeface="Arial"/>
+              </a:rPr>
+              <a:t>▸  Kompetenter Mitarbeiter macht Fehler, die er eigentlich nicht macht → möglicherweise S3 nötig statt S4 (Selbstvertrauen gesunken)</a:t>
+            </a:r>
+          </a:p>
+          <a:p>
+            <a:pPr marL="190500" indent="-190500">
+              <a:spcBef>
+                <a:spcPts val="400"/>
+              </a:spcBef>
+              <a:spcAft>
+                <a:spcPts val="200"/>
+              </a:spcAft>
+            </a:pPr>
+            <a:r>
+              <a:rPr sz="1300">
+                <a:solidFill>
+                  <a:srgbClr val="3D5466"/>
+                </a:solidFill>
+                <a:latin typeface="Arial"/>
+              </a:rPr>
+              <a:t>▸  Mitarbeiter fragt bei Kleinigkeiten ständig nach → Delegationslücke, S4 noch nicht eingesetzt</a:t>
+            </a:r>
+          </a:p>
+          <a:p>
+            <a:pPr marL="190500" indent="-190500">
+              <a:spcBef>
+                <a:spcPts val="400"/>
+              </a:spcBef>
+              <a:spcAft>
+                <a:spcPts val="200"/>
+              </a:spcAft>
+            </a:pPr>
+            <a:r>
+              <a:rPr sz="1300">
+                <a:solidFill>
+                  <a:srgbClr val="3D5466"/>
+                </a:solidFill>
+                <a:latin typeface="Arial"/>
+              </a:rPr>
+              <a:t>▸  Motivation bricht nach neuer Aufgabe ein → Reifegrad ist aufgabenspezifisch auf D1/D2 zurückgefallen → zurück zu S1/S2</a:t>
+            </a:r>
+          </a:p>
+        </p:txBody>
+      </p:sp>
+      <p:sp>
+        <p:nvSpPr>
+          <p:cNvPr id="9" name="Rectangle 8"/>
+          <p:cNvSpPr/>
+          <p:nvPr/>
+        </p:nvSpPr>
+        <p:spPr>
+          <a:xfrm>
+            <a:off x="0" y="6510528"/>
+            <a:ext cx="12188952" cy="347472"/>
+          </a:xfrm>
+          <a:prstGeom prst="rect">
+            <a:avLst/>
+          </a:prstGeom>
+          <a:solidFill>
+            <a:srgbClr val="0A1937"/>
+          </a:solidFill>
+          <a:ln>
+            <a:noFill/>
+          </a:ln>
+        </p:spPr>
+        <p:style>
+          <a:lnRef idx="1">
+            <a:schemeClr val="accent1"/>
+          </a:lnRef>
+          <a:fillRef idx="3">
+            <a:schemeClr val="accent1"/>
+          </a:fillRef>
+          <a:effectRef idx="2">
+            <a:schemeClr val="accent1"/>
+          </a:effectRef>
+          <a:fontRef idx="minor">
+            <a:schemeClr val="lt1"/>
+          </a:fontRef>
+        </p:style>
+        <p:txBody>
+          <a:bodyPr rtlCol="0" anchor="ctr"/>
+          <a:lstStyle/>
+          <a:p>
+            <a:pPr algn="ctr"/>
+          </a:p>
+        </p:txBody>
+      </p:sp>
+      <p:sp>
+        <p:nvSpPr>
+          <p:cNvPr id="10" name="TextBox 9"/>
+          <p:cNvSpPr txBox="1"/>
+          <p:nvPr/>
+        </p:nvSpPr>
+        <p:spPr>
+          <a:xfrm>
+            <a:off x="685800" y="6583680"/>
+            <a:ext cx="6490411" cy="256032"/>
+          </a:xfrm>
+          <a:prstGeom prst="rect">
+            <a:avLst/>
+          </a:prstGeom>
+          <a:noFill/>
+        </p:spPr>
+        <p:txBody>
+          <a:bodyPr wrap="none">
+            <a:spAutoFit/>
+          </a:bodyPr>
+          <a:lstStyle/>
+          <a:p>
+            <a:pPr algn="l"/>
+            <a:r>
+              <a:rPr sz="700">
+                <a:solidFill>
+                  <a:srgbClr val="A0B4D2"/>
+                </a:solidFill>
+                <a:latin typeface="Consolas"/>
+              </a:rPr>
+              <a:t>FKB Campus  ·  TL02</a:t>
+            </a:r>
+          </a:p>
+        </p:txBody>
+      </p:sp>
+    </p:spTree>
+  </p:cSld>
+  <p:clrMapOvr>
+    <a:masterClrMapping/>
+  </p:clrMapOvr>
+</p:sld>
+</file>
+
+<file path=ppt/slides/slide11.xml><?xml version="1.0" encoding="utf-8"?>
+<p:sld xmlns:a="http://schemas.openxmlformats.org/drawingml/2006/main" xmlns:p="http://schemas.openxmlformats.org/presentationml/2006/main" xmlns:r="http://schemas.openxmlformats.org/officeDocument/2006/relationships">
+  <p:cSld>
+    <p:spTree>
+      <p:nvGrpSpPr>
+        <p:cNvPr id="1" name=""/>
+        <p:cNvGrpSpPr/>
+        <p:nvPr/>
+      </p:nvGrpSpPr>
+      <p:grpSpPr/>
+      <p:sp>
+        <p:nvSpPr>
+          <p:cNvPr id="2" name="Rectangle 1"/>
+          <p:cNvSpPr/>
+          <p:nvPr/>
+        </p:nvSpPr>
+        <p:spPr>
+          <a:xfrm>
+            <a:off x="0" y="0"/>
+            <a:ext cx="12188952" cy="6858000"/>
+          </a:xfrm>
+          <a:prstGeom prst="rect">
+            <a:avLst/>
+          </a:prstGeom>
+          <a:solidFill>
+            <a:srgbClr val="EDEDF3"/>
+          </a:solidFill>
+          <a:ln>
+            <a:noFill/>
+          </a:ln>
+        </p:spPr>
+        <p:style>
+          <a:lnRef idx="1">
+            <a:schemeClr val="accent1"/>
+          </a:lnRef>
+          <a:fillRef idx="3">
+            <a:schemeClr val="accent1"/>
+          </a:fillRef>
+          <a:effectRef idx="2">
+            <a:schemeClr val="accent1"/>
+          </a:effectRef>
+          <a:fontRef idx="minor">
+            <a:schemeClr val="lt1"/>
+          </a:fontRef>
+        </p:style>
+        <p:txBody>
+          <a:bodyPr rtlCol="0" anchor="ctr"/>
+          <a:lstStyle/>
+          <a:p>
+            <a:pPr algn="ctr"/>
+          </a:p>
+        </p:txBody>
+      </p:sp>
+      <p:sp>
+        <p:nvSpPr>
+          <p:cNvPr id="3" name="Rectangle 2"/>
+          <p:cNvSpPr/>
+          <p:nvPr/>
+        </p:nvSpPr>
+        <p:spPr>
+          <a:xfrm>
+            <a:off x="0" y="0"/>
+            <a:ext cx="12188952" cy="50292"/>
+          </a:xfrm>
+          <a:prstGeom prst="rect">
+            <a:avLst/>
+          </a:prstGeom>
+          <a:solidFill>
+            <a:srgbClr val="1F2C56"/>
+          </a:solidFill>
+          <a:ln>
+            <a:noFill/>
+          </a:ln>
+        </p:spPr>
+        <p:style>
+          <a:lnRef idx="1">
+            <a:schemeClr val="accent1"/>
+          </a:lnRef>
+          <a:fillRef idx="3">
+            <a:schemeClr val="accent1"/>
+          </a:fillRef>
+          <a:effectRef idx="2">
+            <a:schemeClr val="accent1"/>
+          </a:effectRef>
+          <a:fontRef idx="minor">
+            <a:schemeClr val="lt1"/>
+          </a:fontRef>
+        </p:style>
+        <p:txBody>
+          <a:bodyPr rtlCol="0" anchor="ctr"/>
+          <a:lstStyle/>
+          <a:p>
+            <a:pPr algn="ctr"/>
+          </a:p>
+        </p:txBody>
+      </p:sp>
+      <p:sp>
+        <p:nvSpPr>
+          <p:cNvPr id="4" name="TextBox 3"/>
+          <p:cNvSpPr txBox="1"/>
+          <p:nvPr/>
+        </p:nvSpPr>
+        <p:spPr>
+          <a:xfrm>
+            <a:off x="685800" y="109728"/>
+            <a:ext cx="10817352" cy="228600"/>
+          </a:xfrm>
+          <a:prstGeom prst="rect">
+            <a:avLst/>
+          </a:prstGeom>
+          <a:noFill/>
+        </p:spPr>
+        <p:txBody>
+          <a:bodyPr wrap="none">
+            <a:spAutoFit/>
+          </a:bodyPr>
+          <a:lstStyle/>
+          <a:p>
+            <a:pPr algn="l"/>
+            <a:r>
+              <a:rPr sz="750">
+                <a:solidFill>
+                  <a:srgbClr val="78808C"/>
+                </a:solidFill>
+                <a:latin typeface="Consolas"/>
+              </a:rPr>
+              <a:t>TL02  ·  INHALT</a:t>
+            </a:r>
+          </a:p>
+        </p:txBody>
+      </p:sp>
+      <p:sp>
+        <p:nvSpPr>
+          <p:cNvPr id="5" name="Rectangle 4"/>
+          <p:cNvSpPr/>
+          <p:nvPr/>
+        </p:nvSpPr>
+        <p:spPr>
+          <a:xfrm>
+            <a:off x="0" y="1234440"/>
+            <a:ext cx="12188952" cy="12700"/>
+          </a:xfrm>
+          <a:prstGeom prst="rect">
+            <a:avLst/>
+          </a:prstGeom>
+          <a:solidFill>
+            <a:srgbClr val="D8DFE4"/>
+          </a:solidFill>
+          <a:ln>
+            <a:noFill/>
+          </a:ln>
+        </p:spPr>
+        <p:style>
+          <a:lnRef idx="1">
+            <a:schemeClr val="accent1"/>
+          </a:lnRef>
+          <a:fillRef idx="3">
+            <a:schemeClr val="accent1"/>
+          </a:fillRef>
+          <a:effectRef idx="2">
+            <a:schemeClr val="accent1"/>
+          </a:effectRef>
+          <a:fontRef idx="minor">
+            <a:schemeClr val="lt1"/>
+          </a:fontRef>
+        </p:style>
+        <p:txBody>
+          <a:bodyPr rtlCol="0" anchor="ctr"/>
+          <a:lstStyle/>
+          <a:p>
+            <a:pPr algn="ctr"/>
+          </a:p>
+        </p:txBody>
+      </p:sp>
+      <p:sp>
+        <p:nvSpPr>
+          <p:cNvPr id="6" name="Rectangle 5"/>
+          <p:cNvSpPr/>
+          <p:nvPr/>
+        </p:nvSpPr>
+        <p:spPr>
+          <a:xfrm>
+            <a:off x="685800" y="502920"/>
+            <a:ext cx="36576" cy="658368"/>
+          </a:xfrm>
+          <a:prstGeom prst="rect">
+            <a:avLst/>
+          </a:prstGeom>
+          <a:solidFill>
+            <a:srgbClr val="D9C089"/>
+          </a:solidFill>
+          <a:ln>
+            <a:noFill/>
+          </a:ln>
+        </p:spPr>
+        <p:style>
+          <a:lnRef idx="1">
+            <a:schemeClr val="accent1"/>
+          </a:lnRef>
+          <a:fillRef idx="3">
+            <a:schemeClr val="accent1"/>
+          </a:fillRef>
+          <a:effectRef idx="2">
+            <a:schemeClr val="accent1"/>
+          </a:effectRef>
+          <a:fontRef idx="minor">
+            <a:schemeClr val="lt1"/>
+          </a:fontRef>
+        </p:style>
+        <p:txBody>
+          <a:bodyPr rtlCol="0" anchor="ctr"/>
+          <a:lstStyle/>
+          <a:p>
+            <a:pPr algn="ctr"/>
+          </a:p>
+        </p:txBody>
+      </p:sp>
+      <p:sp>
+        <p:nvSpPr>
+          <p:cNvPr id="7" name="TextBox 6"/>
+          <p:cNvSpPr txBox="1"/>
+          <p:nvPr/>
+        </p:nvSpPr>
+        <p:spPr>
+          <a:xfrm>
+            <a:off x="813816" y="502920"/>
+            <a:ext cx="10634472" cy="685800"/>
+          </a:xfrm>
+          <a:prstGeom prst="rect">
+            <a:avLst/>
+          </a:prstGeom>
+          <a:noFill/>
+        </p:spPr>
+        <p:txBody>
+          <a:bodyPr wrap="square">
+            <a:spAutoFit/>
+          </a:bodyPr>
+          <a:lstStyle/>
+          <a:p>
+            <a:pPr algn="l"/>
+            <a:r>
+              <a:rPr sz="2400" b="1" i="0">
+                <a:solidFill>
+                  <a:srgbClr val="1F2C56"/>
+                </a:solidFill>
+                <a:latin typeface="Arial"/>
+              </a:rPr>
+              <a:t>Checkliste: Führungsstil situativ anpassen</a:t>
+            </a:r>
+          </a:p>
+        </p:txBody>
+      </p:sp>
+      <p:sp>
+        <p:nvSpPr>
+          <p:cNvPr id="8" name="TextBox 7"/>
+          <p:cNvSpPr txBox="1"/>
+          <p:nvPr/>
+        </p:nvSpPr>
+        <p:spPr>
+          <a:xfrm>
+            <a:off x="685800" y="1417320"/>
+            <a:ext cx="10817352" cy="4892040"/>
+          </a:xfrm>
+          <a:prstGeom prst="rect">
+            <a:avLst/>
+          </a:prstGeom>
+          <a:noFill/>
+        </p:spPr>
+        <p:txBody>
+          <a:bodyPr wrap="square">
+            <a:spAutoFit/>
+          </a:bodyPr>
+          <a:lstStyle/>
+          <a:p>
+            <a:pPr>
+              <a:spcBef>
+                <a:spcPts val="400"/>
+              </a:spcBef>
+              <a:spcAft>
+                <a:spcPts val="200"/>
+              </a:spcAft>
+            </a:pPr>
+            <a:r>
+              <a:rPr sz="1200">
+                <a:solidFill>
+                  <a:srgbClr val="3D5466"/>
+                </a:solidFill>
+                <a:latin typeface="Arial"/>
+              </a:rPr>
+              <a:t>Vor jedem Führungsgespräch (&lt; 2 Minuten)</a:t>
+            </a:r>
+          </a:p>
+          <a:p>
+            <a:pPr marL="190500" indent="-190500">
+              <a:spcBef>
+                <a:spcPts val="400"/>
+              </a:spcBef>
+              <a:spcAft>
+                <a:spcPts val="200"/>
+              </a:spcAft>
+            </a:pPr>
+            <a:r>
+              <a:rPr sz="1300">
+                <a:solidFill>
+                  <a:srgbClr val="3D5466"/>
+                </a:solidFill>
+                <a:latin typeface="Arial"/>
+              </a:rPr>
+              <a:t>▸  [ ] Habe ich den Reifegrad des Mitarbeiters für diese konkrete Aufgabe eingeschätzt?</a:t>
+            </a:r>
+          </a:p>
+          <a:p>
+            <a:pPr marL="190500" indent="-190500">
+              <a:spcBef>
+                <a:spcPts val="400"/>
+              </a:spcBef>
+              <a:spcAft>
+                <a:spcPts val="200"/>
+              </a:spcAft>
+            </a:pPr>
+            <a:r>
+              <a:rPr sz="1300">
+                <a:solidFill>
+                  <a:srgbClr val="3D5466"/>
+                </a:solidFill>
+                <a:latin typeface="Arial"/>
+              </a:rPr>
+              <a:t>▸  [ ] Habe ich bewusst einen Führungsstil gewählt – und nicht meinen Standard-Stil eingesetzt?</a:t>
+            </a:r>
+          </a:p>
+          <a:p>
+            <a:pPr marL="190500" indent="-190500">
+              <a:spcBef>
+                <a:spcPts val="400"/>
+              </a:spcBef>
+              <a:spcAft>
+                <a:spcPts val="200"/>
+              </a:spcAft>
+            </a:pPr>
+            <a:r>
+              <a:rPr sz="1300">
+                <a:solidFill>
+                  <a:srgbClr val="3D5466"/>
+                </a:solidFill>
+                <a:latin typeface="Arial"/>
+              </a:rPr>
+              <a:t>▸  [ ] Kenne ich den Unterschied zwischen dem Können und dem Wollen des Mitarbeiters in dieser Situation?</a:t>
+            </a:r>
+          </a:p>
+          <a:p>
+            <a:pPr marL="190500" indent="-190500">
+              <a:spcBef>
+                <a:spcPts val="400"/>
+              </a:spcBef>
+              <a:spcAft>
+                <a:spcPts val="200"/>
+              </a:spcAft>
+            </a:pPr>
+            <a:r>
+              <a:rPr sz="1300">
+                <a:solidFill>
+                  <a:srgbClr val="3D5466"/>
+                </a:solidFill>
+                <a:latin typeface="Arial"/>
+              </a:rPr>
+              <a:t>▸  [ ] Habe ich einen konkreten Einstiegssatz oder eine Frage vorbereitet, die meinen gewählten Stil zeigt?</a:t>
+            </a:r>
+          </a:p>
+          <a:p>
+            <a:pPr>
+              <a:spcBef>
+                <a:spcPts val="400"/>
+              </a:spcBef>
+              <a:spcAft>
+                <a:spcPts val="200"/>
+              </a:spcAft>
+            </a:pPr>
+            <a:r>
+              <a:rPr sz="1200">
+                <a:solidFill>
+                  <a:srgbClr val="3D5466"/>
+                </a:solidFill>
+                <a:latin typeface="Arial"/>
+              </a:rPr>
+              <a:t>Nach dem Gespräch (Kurzreflexion, &lt; 3 Minuten)</a:t>
+            </a:r>
+          </a:p>
+          <a:p>
+            <a:pPr marL="190500" indent="-190500">
+              <a:spcBef>
+                <a:spcPts val="400"/>
+              </a:spcBef>
+              <a:spcAft>
+                <a:spcPts val="200"/>
+              </a:spcAft>
+            </a:pPr>
+            <a:r>
+              <a:rPr sz="1300">
+                <a:solidFill>
+                  <a:srgbClr val="3D5466"/>
+                </a:solidFill>
+                <a:latin typeface="Arial"/>
+              </a:rPr>
+              <a:t>▸  [ ] Hat mein Führungsverhalten zur Situation gepasst? Woran habe ich das gemerkt?</a:t>
+            </a:r>
+          </a:p>
+          <a:p>
+            <a:pPr marL="190500" indent="-190500">
+              <a:spcBef>
+                <a:spcPts val="400"/>
+              </a:spcBef>
+              <a:spcAft>
+                <a:spcPts val="200"/>
+              </a:spcAft>
+            </a:pPr>
+            <a:r>
+              <a:rPr sz="1300">
+                <a:solidFill>
+                  <a:srgbClr val="3D5466"/>
+                </a:solidFill>
+                <a:latin typeface="Arial"/>
+              </a:rPr>
+              <a:t>▸  [ ] Hat der Mitarbeiter so reagiert, wie ich es erwartet habe? Was hat mich überrascht?</a:t>
+            </a:r>
+          </a:p>
+          <a:p>
+            <a:pPr marL="190500" indent="-190500">
+              <a:spcBef>
+                <a:spcPts val="400"/>
+              </a:spcBef>
+              <a:spcAft>
+                <a:spcPts val="200"/>
+              </a:spcAft>
+            </a:pPr>
+            <a:r>
+              <a:rPr sz="1300">
+                <a:solidFill>
+                  <a:srgbClr val="3D5466"/>
+                </a:solidFill>
+                <a:latin typeface="Arial"/>
+              </a:rPr>
+              <a:t>▸  [ ] Müsste ich beim nächsten Gespräch den Stil anpassen?</a:t>
+            </a:r>
+          </a:p>
+          <a:p>
+            <a:pPr>
+              <a:spcBef>
+                <a:spcPts val="400"/>
+              </a:spcBef>
+              <a:spcAft>
+                <a:spcPts val="200"/>
+              </a:spcAft>
+            </a:pPr>
+            <a:r>
+              <a:rPr sz="1200">
+                <a:solidFill>
+                  <a:srgbClr val="3D5466"/>
+                </a:solidFill>
+                <a:latin typeface="Arial"/>
+              </a:rPr>
+              <a:t>Im Team-Rhythmus (monatlich)</a:t>
+            </a:r>
+          </a:p>
+          <a:p>
+            <a:pPr marL="190500" indent="-190500">
+              <a:spcBef>
+                <a:spcPts val="400"/>
+              </a:spcBef>
+              <a:spcAft>
+                <a:spcPts val="200"/>
+              </a:spcAft>
+            </a:pPr>
+            <a:r>
+              <a:rPr sz="1300">
+                <a:solidFill>
+                  <a:srgbClr val="3D5466"/>
+                </a:solidFill>
+                <a:latin typeface="Arial"/>
+              </a:rPr>
+              <a:t>▸  [ ] Bei welchem Mitarbeiter hat sich der Reifegrad in den letzten Wochen verändert?</a:t>
+            </a:r>
+          </a:p>
+          <a:p>
+            <a:pPr marL="190500" indent="-190500">
+              <a:spcBef>
+                <a:spcPts val="400"/>
+              </a:spcBef>
+              <a:spcAft>
+                <a:spcPts val="200"/>
+              </a:spcAft>
+            </a:pPr>
+            <a:r>
+              <a:rPr sz="1300">
+                <a:solidFill>
+                  <a:srgbClr val="3D5466"/>
+                </a:solidFill>
+                <a:latin typeface="Arial"/>
+              </a:rPr>
+              <a:t>▸  [ ] Habe ich meinen Führungsstil entsprechend angepasst – oder führe ich ihn/sie noch wie vor sechs Monaten?</a:t>
+            </a:r>
+          </a:p>
+        </p:txBody>
+      </p:sp>
+      <p:sp>
+        <p:nvSpPr>
+          <p:cNvPr id="9" name="Rectangle 8"/>
+          <p:cNvSpPr/>
+          <p:nvPr/>
+        </p:nvSpPr>
+        <p:spPr>
+          <a:xfrm>
+            <a:off x="0" y="6510528"/>
+            <a:ext cx="12188952" cy="347472"/>
+          </a:xfrm>
+          <a:prstGeom prst="rect">
+            <a:avLst/>
+          </a:prstGeom>
+          <a:solidFill>
+            <a:srgbClr val="0A1937"/>
+          </a:solidFill>
+          <a:ln>
+            <a:noFill/>
+          </a:ln>
+        </p:spPr>
+        <p:style>
+          <a:lnRef idx="1">
+            <a:schemeClr val="accent1"/>
+          </a:lnRef>
+          <a:fillRef idx="3">
+            <a:schemeClr val="accent1"/>
+          </a:fillRef>
+          <a:effectRef idx="2">
+            <a:schemeClr val="accent1"/>
+          </a:effectRef>
+          <a:fontRef idx="minor">
+            <a:schemeClr val="lt1"/>
+          </a:fontRef>
+        </p:style>
+        <p:txBody>
+          <a:bodyPr rtlCol="0" anchor="ctr"/>
+          <a:lstStyle/>
+          <a:p>
+            <a:pPr algn="ctr"/>
+          </a:p>
+        </p:txBody>
+      </p:sp>
+      <p:sp>
+        <p:nvSpPr>
+          <p:cNvPr id="10" name="TextBox 9"/>
+          <p:cNvSpPr txBox="1"/>
+          <p:nvPr/>
+        </p:nvSpPr>
+        <p:spPr>
+          <a:xfrm>
+            <a:off x="685800" y="6583680"/>
+            <a:ext cx="6490411" cy="256032"/>
+          </a:xfrm>
+          <a:prstGeom prst="rect">
+            <a:avLst/>
+          </a:prstGeom>
+          <a:noFill/>
+        </p:spPr>
+        <p:txBody>
+          <a:bodyPr wrap="none">
+            <a:spAutoFit/>
+          </a:bodyPr>
+          <a:lstStyle/>
+          <a:p>
+            <a:pPr algn="l"/>
+            <a:r>
+              <a:rPr sz="700">
+                <a:solidFill>
+                  <a:srgbClr val="A0B4D2"/>
+                </a:solidFill>
+                <a:latin typeface="Consolas"/>
+              </a:rPr>
+              <a:t>FKB Campus  ·  TL02</a:t>
+            </a:r>
+          </a:p>
+        </p:txBody>
+      </p:sp>
+    </p:spTree>
+  </p:cSld>
+  <p:clrMapOvr>
+    <a:masterClrMapping/>
+  </p:clrMapOvr>
+</p:sld>
+</file>
+
+<file path=ppt/slides/slide12.xml><?xml version="1.0" encoding="utf-8"?>
+<p:sld xmlns:a="http://schemas.openxmlformats.org/drawingml/2006/main" xmlns:p="http://schemas.openxmlformats.org/presentationml/2006/main" xmlns:r="http://schemas.openxmlformats.org/officeDocument/2006/relationships">
+  <p:cSld>
+    <p:spTree>
+      <p:nvGrpSpPr>
+        <p:cNvPr id="1" name=""/>
+        <p:cNvGrpSpPr/>
+        <p:nvPr/>
+      </p:nvGrpSpPr>
+      <p:grpSpPr/>
+      <p:sp>
+        <p:nvSpPr>
+          <p:cNvPr id="2" name="Rectangle 1"/>
+          <p:cNvSpPr/>
+          <p:nvPr/>
+        </p:nvSpPr>
+        <p:spPr>
+          <a:xfrm>
+            <a:off x="0" y="0"/>
+            <a:ext cx="12188952" cy="6858000"/>
+          </a:xfrm>
+          <a:prstGeom prst="rect">
+            <a:avLst/>
+          </a:prstGeom>
+          <a:solidFill>
+            <a:srgbClr val="EDEDF3"/>
+          </a:solidFill>
+          <a:ln>
+            <a:noFill/>
+          </a:ln>
+        </p:spPr>
+        <p:style>
+          <a:lnRef idx="1">
+            <a:schemeClr val="accent1"/>
+          </a:lnRef>
+          <a:fillRef idx="3">
+            <a:schemeClr val="accent1"/>
+          </a:fillRef>
+          <a:effectRef idx="2">
+            <a:schemeClr val="accent1"/>
+          </a:effectRef>
+          <a:fontRef idx="minor">
+            <a:schemeClr val="lt1"/>
+          </a:fontRef>
+        </p:style>
+        <p:txBody>
+          <a:bodyPr rtlCol="0" anchor="ctr"/>
+          <a:lstStyle/>
+          <a:p>
+            <a:pPr algn="ctr"/>
+          </a:p>
+        </p:txBody>
+      </p:sp>
+      <p:sp>
+        <p:nvSpPr>
+          <p:cNvPr id="3" name="Rectangle 2"/>
+          <p:cNvSpPr/>
+          <p:nvPr/>
+        </p:nvSpPr>
+        <p:spPr>
+          <a:xfrm>
+            <a:off x="0" y="0"/>
+            <a:ext cx="12188952" cy="50292"/>
+          </a:xfrm>
+          <a:prstGeom prst="rect">
+            <a:avLst/>
+          </a:prstGeom>
+          <a:solidFill>
+            <a:srgbClr val="1F2C56"/>
+          </a:solidFill>
+          <a:ln>
+            <a:noFill/>
+          </a:ln>
+        </p:spPr>
+        <p:style>
+          <a:lnRef idx="1">
+            <a:schemeClr val="accent1"/>
+          </a:lnRef>
+          <a:fillRef idx="3">
+            <a:schemeClr val="accent1"/>
+          </a:fillRef>
+          <a:effectRef idx="2">
+            <a:schemeClr val="accent1"/>
+          </a:effectRef>
+          <a:fontRef idx="minor">
+            <a:schemeClr val="lt1"/>
+          </a:fontRef>
+        </p:style>
+        <p:txBody>
+          <a:bodyPr rtlCol="0" anchor="ctr"/>
+          <a:lstStyle/>
+          <a:p>
+            <a:pPr algn="ctr"/>
+          </a:p>
+        </p:txBody>
+      </p:sp>
+      <p:sp>
+        <p:nvSpPr>
+          <p:cNvPr id="4" name="TextBox 3"/>
+          <p:cNvSpPr txBox="1"/>
+          <p:nvPr/>
+        </p:nvSpPr>
+        <p:spPr>
+          <a:xfrm>
+            <a:off x="685800" y="109728"/>
+            <a:ext cx="10817352" cy="228600"/>
+          </a:xfrm>
+          <a:prstGeom prst="rect">
+            <a:avLst/>
+          </a:prstGeom>
+          <a:noFill/>
+        </p:spPr>
+        <p:txBody>
+          <a:bodyPr wrap="none">
+            <a:spAutoFit/>
+          </a:bodyPr>
+          <a:lstStyle/>
+          <a:p>
+            <a:pPr algn="l"/>
+            <a:r>
+              <a:rPr sz="750">
+                <a:solidFill>
+                  <a:srgbClr val="78808C"/>
+                </a:solidFill>
+                <a:latin typeface="Consolas"/>
+              </a:rPr>
+              <a:t>TL02  ·  INHALT</a:t>
+            </a:r>
+          </a:p>
+        </p:txBody>
+      </p:sp>
+      <p:sp>
+        <p:nvSpPr>
+          <p:cNvPr id="5" name="Rectangle 4"/>
+          <p:cNvSpPr/>
+          <p:nvPr/>
+        </p:nvSpPr>
+        <p:spPr>
+          <a:xfrm>
+            <a:off x="0" y="1234440"/>
+            <a:ext cx="12188952" cy="12700"/>
+          </a:xfrm>
+          <a:prstGeom prst="rect">
+            <a:avLst/>
+          </a:prstGeom>
+          <a:solidFill>
+            <a:srgbClr val="D8DFE4"/>
+          </a:solidFill>
+          <a:ln>
+            <a:noFill/>
+          </a:ln>
+        </p:spPr>
+        <p:style>
+          <a:lnRef idx="1">
+            <a:schemeClr val="accent1"/>
+          </a:lnRef>
+          <a:fillRef idx="3">
+            <a:schemeClr val="accent1"/>
+          </a:fillRef>
+          <a:effectRef idx="2">
+            <a:schemeClr val="accent1"/>
+          </a:effectRef>
+          <a:fontRef idx="minor">
+            <a:schemeClr val="lt1"/>
+          </a:fontRef>
+        </p:style>
+        <p:txBody>
+          <a:bodyPr rtlCol="0" anchor="ctr"/>
+          <a:lstStyle/>
+          <a:p>
+            <a:pPr algn="ctr"/>
+          </a:p>
+        </p:txBody>
+      </p:sp>
+      <p:sp>
+        <p:nvSpPr>
+          <p:cNvPr id="6" name="Rectangle 5"/>
+          <p:cNvSpPr/>
+          <p:nvPr/>
+        </p:nvSpPr>
+        <p:spPr>
+          <a:xfrm>
+            <a:off x="685800" y="502920"/>
+            <a:ext cx="36576" cy="658368"/>
+          </a:xfrm>
+          <a:prstGeom prst="rect">
+            <a:avLst/>
+          </a:prstGeom>
+          <a:solidFill>
+            <a:srgbClr val="D9C089"/>
+          </a:solidFill>
+          <a:ln>
+            <a:noFill/>
+          </a:ln>
+        </p:spPr>
+        <p:style>
+          <a:lnRef idx="1">
+            <a:schemeClr val="accent1"/>
+          </a:lnRef>
+          <a:fillRef idx="3">
+            <a:schemeClr val="accent1"/>
+          </a:fillRef>
+          <a:effectRef idx="2">
+            <a:schemeClr val="accent1"/>
+          </a:effectRef>
+          <a:fontRef idx="minor">
+            <a:schemeClr val="lt1"/>
+          </a:fontRef>
+        </p:style>
+        <p:txBody>
+          <a:bodyPr rtlCol="0" anchor="ctr"/>
+          <a:lstStyle/>
+          <a:p>
+            <a:pPr algn="ctr"/>
+          </a:p>
+        </p:txBody>
+      </p:sp>
+      <p:sp>
+        <p:nvSpPr>
+          <p:cNvPr id="7" name="TextBox 6"/>
+          <p:cNvSpPr txBox="1"/>
+          <p:nvPr/>
+        </p:nvSpPr>
+        <p:spPr>
+          <a:xfrm>
+            <a:off x="813816" y="502920"/>
+            <a:ext cx="10634472" cy="685800"/>
+          </a:xfrm>
+          <a:prstGeom prst="rect">
+            <a:avLst/>
+          </a:prstGeom>
+          <a:noFill/>
+        </p:spPr>
+        <p:txBody>
+          <a:bodyPr wrap="square">
+            <a:spAutoFit/>
+          </a:bodyPr>
+          <a:lstStyle/>
+          <a:p>
+            <a:pPr algn="l"/>
+            <a:r>
+              <a:rPr sz="2400" b="1" i="0">
+                <a:solidFill>
+                  <a:srgbClr val="1F2C56"/>
+                </a:solidFill>
+                <a:latin typeface="Arial"/>
+              </a:rPr>
               <a:t>Reflexionsfragen</a:t>
             </a:r>
           </a:p>
@@ -5631,7 +6881,7 @@
                 </a:solidFill>
                 <a:latin typeface="Arial"/>
               </a:rPr>
-              <a:t>▸  Die vier Führungsstile des situativen Modells nach Hersey und Blanchard (dirigieren, trainieren, sekundieren, delegieren) sowie das zugrundeliegende Reifegrad-Konstrukt (Kompetenz × Motivation) erklären</a:t>
+              <a:t>▸  Die vier Führungsstile des situativen Modells nach Hersey und Blanchard (dirigieren, coachen/trainieren, sekundieren, delegieren) sowie das zugrundeliegende Reifegrad-Konstrukt (Kompetenz × Motivation) erklären</a:t>
             </a:r>
           </a:p>
           <a:p>
@@ -5905,7 +7155,7 @@
                 </a:solidFill>
                 <a:latin typeface="Consolas"/>
               </a:rPr>
-              <a:t>TL02  ·  INHALT</a:t>
+              <a:t>AGENDA  ·  TL02</a:t>
             </a:r>
           </a:p>
         </p:txBody>
@@ -5955,57 +7205,14 @@
       </p:sp>
       <p:sp>
         <p:nvSpPr>
-          <p:cNvPr id="6" name="Rectangle 5"/>
-          <p:cNvSpPr/>
+          <p:cNvPr id="6" name="TextBox 5"/>
+          <p:cNvSpPr txBox="1"/>
           <p:nvPr/>
         </p:nvSpPr>
         <p:spPr>
           <a:xfrm>
             <a:off x="685800" y="502920"/>
-            <a:ext cx="36576" cy="658368"/>
-          </a:xfrm>
-          <a:prstGeom prst="rect">
-            <a:avLst/>
-          </a:prstGeom>
-          <a:solidFill>
-            <a:srgbClr val="D9C089"/>
-          </a:solidFill>
-          <a:ln>
-            <a:noFill/>
-          </a:ln>
-        </p:spPr>
-        <p:style>
-          <a:lnRef idx="1">
-            <a:schemeClr val="accent1"/>
-          </a:lnRef>
-          <a:fillRef idx="3">
-            <a:schemeClr val="accent1"/>
-          </a:fillRef>
-          <a:effectRef idx="2">
-            <a:schemeClr val="accent1"/>
-          </a:effectRef>
-          <a:fontRef idx="minor">
-            <a:schemeClr val="lt1"/>
-          </a:fontRef>
-        </p:style>
-        <p:txBody>
-          <a:bodyPr rtlCol="0" anchor="ctr"/>
-          <a:lstStyle/>
-          <a:p>
-            <a:pPr algn="ctr"/>
-          </a:p>
-        </p:txBody>
-      </p:sp>
-      <p:sp>
-        <p:nvSpPr>
-          <p:cNvPr id="7" name="TextBox 6"/>
-          <p:cNvSpPr txBox="1"/>
-          <p:nvPr/>
-        </p:nvSpPr>
-        <p:spPr>
-          <a:xfrm>
-            <a:off x="813816" y="502920"/>
-            <a:ext cx="10634472" cy="685800"/>
+            <a:ext cx="10817352" cy="658368"/>
           </a:xfrm>
           <a:prstGeom prst="rect">
             <a:avLst/>
@@ -6020,27 +7227,27 @@
           <a:p>
             <a:pPr algn="l"/>
             <a:r>
-              <a:rPr sz="2400" b="1" i="0">
+              <a:rPr sz="2600" b="1" i="0">
                 <a:solidFill>
                   <a:srgbClr val="1F2C56"/>
                 </a:solidFill>
                 <a:latin typeface="Arial"/>
               </a:rPr>
-              <a:t>Theorie-Input: Warum es keinen universell richtigen Führungsstil gibt</a:t>
-            </a:r>
-          </a:p>
-        </p:txBody>
-      </p:sp>
-      <p:sp>
-        <p:nvSpPr>
-          <p:cNvPr id="8" name="TextBox 7"/>
+              <a:t>So läuft das Modul</a:t>
+            </a:r>
+          </a:p>
+        </p:txBody>
+      </p:sp>
+      <p:sp>
+        <p:nvSpPr>
+          <p:cNvPr id="7" name="TextBox 6"/>
           <p:cNvSpPr txBox="1"/>
           <p:nvPr/>
         </p:nvSpPr>
         <p:spPr>
           <a:xfrm>
-            <a:off x="685800" y="1417320"/>
-            <a:ext cx="10817352" cy="4892040"/>
+            <a:off x="685800" y="1463040"/>
+            <a:ext cx="10817352" cy="4937760"/>
           </a:xfrm>
           <a:prstGeom prst="rect">
             <a:avLst/>
@@ -6058,17 +7265,35 @@
                 <a:spcPts val="400"/>
               </a:spcBef>
               <a:spcAft>
-                <a:spcPts val="200"/>
+                <a:spcPts val="100"/>
               </a:spcAft>
             </a:pPr>
             <a:r>
-              <a:rPr sz="1200">
+              <a:rPr sz="900">
+                <a:solidFill>
+                  <a:srgbClr val="78808C"/>
+                </a:solidFill>
+                <a:latin typeface="Consolas"/>
+              </a:rPr>
+              <a:t>08:30–08:45 </a:t>
+            </a:r>
+            <a:r>
+              <a:rPr sz="1200" b="1">
                 <a:solidFill>
                   <a:srgbClr val="3D5466"/>
                 </a:solidFill>
                 <a:latin typeface="Arial"/>
               </a:rPr>
-              <a:t>Die Grundfrage</a:t>
+              <a:t>  Ankommen &amp; Einstieg</a:t>
+            </a:r>
+            <a:r>
+              <a:rPr sz="900">
+                <a:solidFill>
+                  <a:srgbClr val="78808C"/>
+                </a:solidFill>
+                <a:latin typeface="Arial"/>
+              </a:rPr>
+              <a:t>  ·  Begrüßung, Vorstellungsrunde (Name, Team, eine Führungssituation aus der letzten Woche)</a:t>
             </a:r>
           </a:p>
           <a:p>
@@ -6077,17 +7302,35 @@
                 <a:spcPts val="400"/>
               </a:spcBef>
               <a:spcAft>
-                <a:spcPts val="200"/>
+                <a:spcPts val="100"/>
               </a:spcAft>
             </a:pPr>
             <a:r>
-              <a:rPr sz="1200">
+              <a:rPr sz="900">
+                <a:solidFill>
+                  <a:srgbClr val="78808C"/>
+                </a:solidFill>
+                <a:latin typeface="Consolas"/>
+              </a:rPr>
+              <a:t>08:45–09:00 </a:t>
+            </a:r>
+            <a:r>
+              <a:rPr sz="1200" b="1">
                 <a:solidFill>
                   <a:srgbClr val="3D5466"/>
                 </a:solidFill>
                 <a:latin typeface="Arial"/>
               </a:rPr>
-              <a:t>Die Frage ist deshalb nicht „Was ist mein Führungsstil?", sondern: „Welcher Stil ist hier, jetzt, für diesen Menschen bei dieser Aufgabe richtig?"</a:t>
+              <a:t>  Aktivierung: Stilbefragung</a:t>
+            </a:r>
+            <a:r>
+              <a:rPr sz="900">
+                <a:solidFill>
+                  <a:srgbClr val="78808C"/>
+                </a:solidFill>
+                <a:latin typeface="Arial"/>
+              </a:rPr>
+              <a:t>  ·  Einzelarbeit: Jeder notiert, welchen Führungsstil er gestern oder vorgestern eingesetzt hat – und warum. Kurze Spontanmeldungen im Plenum (kein Bewertungsformat).</a:t>
             </a:r>
           </a:p>
           <a:p>
@@ -6096,17 +7339,35 @@
                 <a:spcPts val="400"/>
               </a:spcBef>
               <a:spcAft>
-                <a:spcPts val="200"/>
+                <a:spcPts val="100"/>
               </a:spcAft>
             </a:pPr>
             <a:r>
-              <a:rPr sz="1200">
+              <a:rPr sz="900">
+                <a:solidFill>
+                  <a:srgbClr val="78808C"/>
+                </a:solidFill>
+                <a:latin typeface="Consolas"/>
+              </a:rPr>
+              <a:t>09:00–09:40 </a:t>
+            </a:r>
+            <a:r>
+              <a:rPr sz="1200" b="1">
                 <a:solidFill>
                   <a:srgbClr val="3D5466"/>
                 </a:solidFill>
                 <a:latin typeface="Arial"/>
               </a:rPr>
-              <a:t>Kurzer Bogen der Stilforschung</a:t>
+              <a:t>  Theorie-Input: Vom Verhaltensgitter zum situativen Modell</a:t>
+            </a:r>
+            <a:r>
+              <a:rPr sz="900">
+                <a:solidFill>
+                  <a:srgbClr val="78808C"/>
+                </a:solidFill>
+                <a:latin typeface="Arial"/>
+              </a:rPr>
+              <a:t>  ·  Trainerinput mit Visualisierung (Folie/Flipchart): Forschungsbogen Blake/Mouton → Fiedler → Hersey/Blanchard. D1–D4/S1–S4-Matrix erarbeiten. D2 als kritisches Stadium besonders erläutern. Aufgabenbezug des Reifegrades betonen.</a:t>
             </a:r>
           </a:p>
           <a:p>
@@ -6115,17 +7376,35 @@
                 <a:spcPts val="400"/>
               </a:spcBef>
               <a:spcAft>
-                <a:spcPts val="200"/>
+                <a:spcPts val="100"/>
               </a:spcAft>
             </a:pPr>
             <a:r>
-              <a:rPr sz="1200">
+              <a:rPr sz="900">
+                <a:solidFill>
+                  <a:srgbClr val="78808C"/>
+                </a:solidFill>
+                <a:latin typeface="Consolas"/>
+              </a:rPr>
+              <a:t>09:40–10:00 </a:t>
+            </a:r>
+            <a:r>
+              <a:rPr sz="1200" b="1">
                 <a:solidFill>
                   <a:srgbClr val="3D5466"/>
                 </a:solidFill>
                 <a:latin typeface="Arial"/>
               </a:rPr>
-              <a:t>Das Kernmodell: Situatives Führen nach Hersey und Blanchard</a:t>
+              <a:t>  Theorie verankern: Vier-Felder-Quiz</a:t>
+            </a:r>
+            <a:r>
+              <a:rPr sz="900">
+                <a:solidFill>
+                  <a:srgbClr val="78808C"/>
+                </a:solidFill>
+                <a:latin typeface="Arial"/>
+              </a:rPr>
+              <a:t>  ·  Trainer nennt 4 Kurzfälle (je 2–3 Sätze), TN ordnen auf Karten: Welcher Reifegrad? Welcher Stil? Karten hochhalten, kurzes Blitzfeedback. Keine Auflösung als Richtig/Falsch – Diskussion der Einschätzungsunterschiede.</a:t>
             </a:r>
           </a:p>
           <a:p>
@@ -6134,55 +7413,26 @@
                 <a:spcPts val="400"/>
               </a:spcBef>
               <a:spcAft>
-                <a:spcPts val="200"/>
+                <a:spcPts val="100"/>
               </a:spcAft>
             </a:pPr>
             <a:r>
-              <a:rPr sz="1200">
+              <a:rPr sz="900">
+                <a:solidFill>
+                  <a:srgbClr val="78808C"/>
+                </a:solidFill>
+                <a:latin typeface="Consolas"/>
+              </a:rPr>
+              <a:t>10:00–10:15 </a:t>
+            </a:r>
+            <a:r>
+              <a:rPr sz="1200" b="1">
                 <a:solidFill>
                   <a:srgbClr val="3D5466"/>
                 </a:solidFill>
                 <a:latin typeface="Arial"/>
               </a:rPr>
-              <a:t>Der Reifegrad ergibt sich aus zwei Dimensionen:</a:t>
-            </a:r>
-          </a:p>
-          <a:p>
-            <a:pPr marL="190500" indent="-190500">
-              <a:spcBef>
-                <a:spcPts val="400"/>
-              </a:spcBef>
-              <a:spcAft>
-                <a:spcPts val="200"/>
-              </a:spcAft>
-            </a:pPr>
-            <a:r>
-              <a:rPr sz="1300">
-                <a:solidFill>
-                  <a:srgbClr val="3D5466"/>
-                </a:solidFill>
-                <a:latin typeface="Arial"/>
-              </a:rPr>
-              <a:t>▸  Kompetenz: Fachliches Können, Erfahrung, relevante Kenntnisse für genau diese Aufgabe</a:t>
-            </a:r>
-          </a:p>
-          <a:p>
-            <a:pPr marL="190500" indent="-190500">
-              <a:spcBef>
-                <a:spcPts val="400"/>
-              </a:spcBef>
-              <a:spcAft>
-                <a:spcPts val="200"/>
-              </a:spcAft>
-            </a:pPr>
-            <a:r>
-              <a:rPr sz="1300">
-                <a:solidFill>
-                  <a:srgbClr val="3D5466"/>
-                </a:solidFill>
-                <a:latin typeface="Arial"/>
-              </a:rPr>
-              <a:t>▸  Engagement/Selbstvertrauen: Motivation, Bereitschaft, Zutrauen in die eigene Leistung</a:t>
+              <a:t>  Pause</a:t>
             </a:r>
           </a:p>
           <a:p>
@@ -6191,17 +7441,35 @@
                 <a:spcPts val="400"/>
               </a:spcBef>
               <a:spcAft>
-                <a:spcPts val="200"/>
+                <a:spcPts val="100"/>
               </a:spcAft>
             </a:pPr>
             <a:r>
-              <a:rPr sz="1200">
+              <a:rPr sz="900">
+                <a:solidFill>
+                  <a:srgbClr val="78808C"/>
+                </a:solidFill>
+                <a:latin typeface="Consolas"/>
+              </a:rPr>
+              <a:t>10:15–10:25 </a:t>
+            </a:r>
+            <a:r>
+              <a:rPr sz="1200" b="1">
                 <a:solidFill>
                   <a:srgbClr val="3D5466"/>
                 </a:solidFill>
                 <a:latin typeface="Arial"/>
               </a:rPr>
-              <a:t>Tabelle nach Hersey &amp; Blanchard (1996, S. 189–213)</a:t>
+              <a:t>  Selbstreflexion: Mein Standard-Führungsstil</a:t>
+            </a:r>
+            <a:r>
+              <a:rPr sz="900">
+                <a:solidFill>
+                  <a:srgbClr val="78808C"/>
+                </a:solidFill>
+                <a:latin typeface="Arial"/>
+              </a:rPr>
+              <a:t>  ·  Einzelarbeit, still (5–7 Min.): Selbstreflexionsfragen aus Sec 4 (Leitfragen 1–3). Kein Sammeln im Plenum – Ergebnis bleibt persönlich. Überleitung: „Was Sie jetzt aufgeschrieben haben, bringen Sie gleich in die Fallarbeit mit."</a:t>
             </a:r>
           </a:p>
           <a:p>
@@ -6210,17 +7478,35 @@
                 <a:spcPts val="400"/>
               </a:spcBef>
               <a:spcAft>
-                <a:spcPts val="200"/>
+                <a:spcPts val="100"/>
               </a:spcAft>
             </a:pPr>
             <a:r>
-              <a:rPr sz="1200">
+              <a:rPr sz="900">
+                <a:solidFill>
+                  <a:srgbClr val="78808C"/>
+                </a:solidFill>
+                <a:latin typeface="Consolas"/>
+              </a:rPr>
+              <a:t>10:25–10:45 </a:t>
+            </a:r>
+            <a:r>
+              <a:rPr sz="1200" b="1">
                 <a:solidFill>
                   <a:srgbClr val="3D5466"/>
                 </a:solidFill>
                 <a:latin typeface="Arial"/>
               </a:rPr>
-              <a:t>Hinweis zu D2 – das kritischste Stadium</a:t>
+              <a:t>  Praxisfall Marlies/Jonas/Sigrid</a:t>
+            </a:r>
+            <a:r>
+              <a:rPr sz="900">
+                <a:solidFill>
+                  <a:srgbClr val="78808C"/>
+                </a:solidFill>
+                <a:latin typeface="Arial"/>
+              </a:rPr>
+              <a:t>  ·  Trainerinput: Praxisfall vorstellen (bis inkl. Führungsstil-Entscheidung). TN lesen parallel mit (Teilnehmerunterlagen). Impuls-Frage: „Wie würden Sie bei Sigrid vorgehen – und warum?" Plenumsblitz (max. 3 Wortmeldungen). Trainer klärt D3-Diagnose und Grenze Wertekonflikt vs. D3.</a:t>
             </a:r>
           </a:p>
           <a:p>
@@ -6229,17 +7515,35 @@
                 <a:spcPts val="400"/>
               </a:spcBef>
               <a:spcAft>
-                <a:spcPts val="200"/>
+                <a:spcPts val="100"/>
               </a:spcAft>
             </a:pPr>
             <a:r>
-              <a:rPr sz="1200">
+              <a:rPr sz="900">
+                <a:solidFill>
+                  <a:srgbClr val="78808C"/>
+                </a:solidFill>
+                <a:latin typeface="Consolas"/>
+              </a:rPr>
+              <a:t>10:45–11:10 </a:t>
+            </a:r>
+            <a:r>
+              <a:rPr sz="1200" b="1">
                 <a:solidFill>
                   <a:srgbClr val="3D5466"/>
                 </a:solidFill>
                 <a:latin typeface="Arial"/>
               </a:rPr>
-              <a:t>Tabelle nach Hersey &amp; Blanchard (1996, S. 200–208)</a:t>
+              <a:t>  Fall-Fortführung: Konsequenzgespräch</a:t>
+            </a:r>
+            <a:r>
+              <a:rPr sz="900">
+                <a:solidFill>
+                  <a:srgbClr val="78808C"/>
+                </a:solidFill>
+                <a:latin typeface="Arial"/>
+              </a:rPr>
+              <a:t>  ·  Trainer führt Fall-Fortführung ein (Sigrid hat Tool weiterhin nicht genutzt). Erläutert Struktur des Konsequenzgesprächs (Sachverhalt, Vereinbarung, Erwartung).</a:t>
             </a:r>
           </a:p>
           <a:p>
@@ -6248,43 +7552,218 @@
                 <a:spcPts val="400"/>
               </a:spcBef>
               <a:spcAft>
-                <a:spcPts val="200"/>
+                <a:spcPts val="100"/>
               </a:spcAft>
             </a:pPr>
             <a:r>
-              <a:rPr sz="1200">
+              <a:rPr sz="900">
+                <a:solidFill>
+                  <a:srgbClr val="78808C"/>
+                </a:solidFill>
+                <a:latin typeface="Consolas"/>
+              </a:rPr>
+              <a:t>11:10–11:45 </a:t>
+            </a:r>
+            <a:r>
+              <a:rPr sz="1200" b="1">
                 <a:solidFill>
                   <a:srgbClr val="3D5466"/>
                 </a:solidFill>
                 <a:latin typeface="Arial"/>
               </a:rPr>
-              <a:t>Brücke zur transformationalen Führung</a:t>
-            </a:r>
-          </a:p>
-          <a:p>
-            <a:pPr marL="190500" indent="-190500">
+              <a:t>  Kollegiale Fallberatung: Sprachcheck</a:t>
+            </a:r>
+            <a:r>
+              <a:rPr sz="900">
+                <a:solidFill>
+                  <a:srgbClr val="78808C"/>
+                </a:solidFill>
+                <a:latin typeface="Arial"/>
+              </a:rPr>
+              <a:t>  ·  Dreiergruppen (35 Min. inkl. Einzelarbeit). Format aus Sec 4: Ausgangsfall A oder eigener Fall (Fall B). Schritt 1 (5 Min.), Schritt 2 (7–10 Min. Einzelarbeit), Schritt 3 (ca. 15 Min. Dreiergruppe). Trainer rotiert durch die Gruppen (kein Eingriff in die Inhalte – nur Zeitcheck und ggf. Prozesshinweis). Kurzauswertung im Plenum (5 Min.): Was hat überrascht? Was ändert sich an der Formulierung?</a:t>
+            </a:r>
+          </a:p>
+          <a:p>
+            <a:pPr>
               <a:spcBef>
                 <a:spcPts val="400"/>
               </a:spcBef>
               <a:spcAft>
-                <a:spcPts val="200"/>
+                <a:spcPts val="100"/>
               </a:spcAft>
             </a:pPr>
             <a:r>
-              <a:rPr sz="1300">
+              <a:rPr sz="900">
+                <a:solidFill>
+                  <a:srgbClr val="78808C"/>
+                </a:solidFill>
+                <a:latin typeface="Consolas"/>
+              </a:rPr>
+              <a:t>11:45–12:05 </a:t>
+            </a:r>
+            <a:r>
+              <a:rPr sz="1200" b="1">
                 <a:solidFill>
                   <a:srgbClr val="3D5466"/>
                 </a:solidFill>
                 <a:latin typeface="Arial"/>
               </a:rPr>
-              <a:t>▸  I1 – Idealized Influence (Vorbildwirkung): Die Führungskraft verkörpert Werte, schafft Identifikation</a:t>
-            </a:r>
-          </a:p>
-        </p:txBody>
-      </p:sp>
-      <p:sp>
-        <p:nvSpPr>
-          <p:cNvPr id="9" name="Rectangle 8"/>
+              <a:t>  AB-1: Diagnose-Arbeitsblatt</a:t>
+            </a:r>
+            <a:r>
+              <a:rPr sz="900">
+                <a:solidFill>
+                  <a:srgbClr val="78808C"/>
+                </a:solidFill>
+                <a:latin typeface="Arial"/>
+              </a:rPr>
+              <a:t>  ·  Einzelarbeit: AB-1 vollständig ausfüllen (12 Min.). Trainer kündigt an: „Bitte einen echten Mitarbeiter, eine echte Aufgabe." Danach: Ein TN stellt seine Einschätzung freiwillig vor – kollegialer Abgleich der Diagnose-Logik (5 Min., kein Richtig/Falsch).</a:t>
+            </a:r>
+          </a:p>
+          <a:p>
+            <a:pPr>
+              <a:spcBef>
+                <a:spcPts val="400"/>
+              </a:spcBef>
+              <a:spcAft>
+                <a:spcPts val="100"/>
+              </a:spcAft>
+            </a:pPr>
+            <a:r>
+              <a:rPr sz="900">
+                <a:solidFill>
+                  <a:srgbClr val="78808C"/>
+                </a:solidFill>
+                <a:latin typeface="Consolas"/>
+              </a:rPr>
+              <a:t>12:05–12:15 </a:t>
+            </a:r>
+            <a:r>
+              <a:rPr sz="1200" b="1">
+                <a:solidFill>
+                  <a:srgbClr val="3D5466"/>
+                </a:solidFill>
+                <a:latin typeface="Arial"/>
+              </a:rPr>
+              <a:t>  Transformationale Führung &amp; Servant Leadership</a:t>
+            </a:r>
+            <a:r>
+              <a:rPr sz="900">
+                <a:solidFill>
+                  <a:srgbClr val="78808C"/>
+                </a:solidFill>
+                <a:latin typeface="Arial"/>
+              </a:rPr>
+              <a:t>  ·  Kurzinput (10 Min.): Vier I nach Bass/Avolio als Entwicklungsrichtung. Servant-Leadership-Leitbild des FKB Campus – genossenschaftliche Verknüpfung (§ 1 GenG). Reflexionsfragen aus Sec 4 als Leseauftrag für nach dem Workshop.</a:t>
+            </a:r>
+          </a:p>
+          <a:p>
+            <a:pPr>
+              <a:spcBef>
+                <a:spcPts val="400"/>
+              </a:spcBef>
+              <a:spcAft>
+                <a:spcPts val="100"/>
+              </a:spcAft>
+            </a:pPr>
+            <a:r>
+              <a:rPr sz="900">
+                <a:solidFill>
+                  <a:srgbClr val="78808C"/>
+                </a:solidFill>
+                <a:latin typeface="Consolas"/>
+              </a:rPr>
+              <a:t>12:15–12:25 </a:t>
+            </a:r>
+            <a:r>
+              <a:rPr sz="1200" b="1">
+                <a:solidFill>
+                  <a:srgbClr val="3D5466"/>
+                </a:solidFill>
+                <a:latin typeface="Arial"/>
+              </a:rPr>
+              <a:t>  Transfer &amp; Abschluss</a:t>
+            </a:r>
+            <a:r>
+              <a:rPr sz="900">
+                <a:solidFill>
+                  <a:srgbClr val="78808C"/>
+                </a:solidFill>
+                <a:latin typeface="Arial"/>
+              </a:rPr>
+              <a:t>  ·  Praxistransfer-Aufgabe vorstellen (Sec 5: zwei Mitarbeiter, je AB-1 + bewusster Stilentscheid; AB-2 als Transferaufgabe für zuhause). Selbstcheck-Formular aushändigen. Ausblick TL04.</a:t>
+            </a:r>
+          </a:p>
+          <a:p>
+            <a:pPr>
+              <a:spcBef>
+                <a:spcPts val="400"/>
+              </a:spcBef>
+              <a:spcAft>
+                <a:spcPts val="100"/>
+              </a:spcAft>
+            </a:pPr>
+            <a:r>
+              <a:rPr sz="900">
+                <a:solidFill>
+                  <a:srgbClr val="78808C"/>
+                </a:solidFill>
+                <a:latin typeface="Consolas"/>
+              </a:rPr>
+              <a:t>12:25–12:30 </a:t>
+            </a:r>
+            <a:r>
+              <a:rPr sz="1200" b="1">
+                <a:solidFill>
+                  <a:srgbClr val="3D5466"/>
+                </a:solidFill>
+                <a:latin typeface="Arial"/>
+              </a:rPr>
+              <a:t>  Evaluation</a:t>
+            </a:r>
+            <a:r>
+              <a:rPr sz="900">
+                <a:solidFill>
+                  <a:srgbClr val="78808C"/>
+                </a:solidFill>
+                <a:latin typeface="Arial"/>
+              </a:rPr>
+              <a:t>  ·  Feedbackbogen austeilen und ausfüllen lassen. Wissenstest optional als Take-away.</a:t>
+            </a:r>
+          </a:p>
+          <a:p>
+            <a:pPr>
+              <a:spcBef>
+                <a:spcPts val="400"/>
+              </a:spcBef>
+              <a:spcAft>
+                <a:spcPts val="100"/>
+              </a:spcAft>
+            </a:pPr>
+            <a:r>
+              <a:rPr sz="900">
+                <a:solidFill>
+                  <a:srgbClr val="78808C"/>
+                </a:solidFill>
+                <a:latin typeface="Consolas"/>
+              </a:rPr>
+              <a:t>Gesamt      </a:t>
+            </a:r>
+            <a:r>
+              <a:rPr sz="1200" b="1">
+                <a:solidFill>
+                  <a:srgbClr val="3D5466"/>
+                </a:solidFill>
+                <a:latin typeface="Arial"/>
+              </a:rPr>
+              <a:t>  </a:t>
+            </a:r>
+          </a:p>
+        </p:txBody>
+      </p:sp>
+      <p:sp>
+        <p:nvSpPr>
+          <p:cNvPr id="8" name="Rectangle 7"/>
           <p:cNvSpPr/>
           <p:nvPr/>
         </p:nvSpPr>
@@ -6327,7 +7806,7 @@
       </p:sp>
       <p:sp>
         <p:nvSpPr>
-          <p:cNvPr id="10" name="TextBox 9"/>
+          <p:cNvPr id="9" name="TextBox 8"/>
           <p:cNvSpPr txBox="1"/>
           <p:nvPr/>
         </p:nvSpPr>
@@ -6615,7 +8094,7 @@
                 </a:solidFill>
                 <a:latin typeface="Arial"/>
               </a:rPr>
-              <a:t>Praxisfall: Zwei Berater, ein Teamleiter, zwei Führungsstile</a:t>
+              <a:t>Theorie-Input: Warum es keinen universell richtigen Führungsstil gibt</a:t>
             </a:r>
           </a:p>
         </p:txBody>
@@ -6657,7 +8136,7 @@
                 </a:solidFill>
                 <a:latin typeface="Arial"/>
               </a:rPr>
-              <a:t>Ausgangslage</a:t>
+              <a:t>Die Grundfrage</a:t>
             </a:r>
           </a:p>
           <a:p>
@@ -6676,7 +8155,7 @@
                 </a:solidFill>
                 <a:latin typeface="Arial"/>
               </a:rPr>
-              <a:t>Die Führungssituation</a:t>
+              <a:t>Die Frage ist deshalb nicht „Was ist mein Führungsstil?", sondern: „Welcher Stil ist hier, jetzt, für diesen Menschen bei dieser Aufgabe richtig?"</a:t>
             </a:r>
           </a:p>
           <a:p>
@@ -6695,7 +8174,45 @@
                 </a:solidFill>
                 <a:latin typeface="Arial"/>
               </a:rPr>
-              <a:t>Marlies steht vor zwei gleichzeitigen Führungsaufgaben:</a:t>
+              <a:t>Kurzer Bogen der Stilforschung</a:t>
+            </a:r>
+          </a:p>
+          <a:p>
+            <a:pPr>
+              <a:spcBef>
+                <a:spcPts val="400"/>
+              </a:spcBef>
+              <a:spcAft>
+                <a:spcPts val="200"/>
+              </a:spcAft>
+            </a:pPr>
+            <a:r>
+              <a:rPr sz="1200">
+                <a:solidFill>
+                  <a:srgbClr val="3D5466"/>
+                </a:solidFill>
+                <a:latin typeface="Arial"/>
+              </a:rPr>
+              <a:t>Das Kernmodell: Situatives Führen nach Hersey und Blanchard</a:t>
+            </a:r>
+          </a:p>
+          <a:p>
+            <a:pPr>
+              <a:spcBef>
+                <a:spcPts val="400"/>
+              </a:spcBef>
+              <a:spcAft>
+                <a:spcPts val="200"/>
+              </a:spcAft>
+            </a:pPr>
+            <a:r>
+              <a:rPr sz="1200">
+                <a:solidFill>
+                  <a:srgbClr val="3D5466"/>
+                </a:solidFill>
+                <a:latin typeface="Arial"/>
+              </a:rPr>
+              <a:t>Der Reifegrad ergibt sich aus zwei Dimensionen:</a:t>
             </a:r>
           </a:p>
           <a:p>
@@ -6714,7 +8231,7 @@
                 </a:solidFill>
                 <a:latin typeface="Arial"/>
               </a:rPr>
-              <a:t>▸  Jonas soll die erste eigenständige Kreditunterlagenprüfung für einen mittelständischen Kunden (Umsatz ca. 12 Mio. EUR, Jahresabschluss vorliegend) vorbereiten – eine Aufgabe, die er strukturiert angehen kann, bei der er aber noch fachliche Unterstützung braucht.</a:t>
+              <a:t>▸  Kompetenz: Fachliches Können, Erfahrung, relevante Kenntnisse für genau diese Aufgabe</a:t>
             </a:r>
           </a:p>
           <a:p>
@@ -6733,7 +8250,7 @@
                 </a:solidFill>
                 <a:latin typeface="Arial"/>
               </a:rPr>
-              <a:t>▸  Sigrid soll das neue Ratingtool bis Ende des Quartals für alle ihre Kreditfälle routinemäßig nutzen. Die Ablehnung gefährdet die Datenkonsistenz im Team und verstößt gegen die interne Vorgabe zur Nutzung des Bewertungssystems gem. § 18 KWG-Dokumentationsstandard.</a:t>
+              <a:t>▸  Engagement/Selbstvertrauen: Motivation, Bereitschaft, Zutrauen in die eigene Leistung</a:t>
             </a:r>
           </a:p>
           <a:p>
@@ -6752,7 +8269,7 @@
                 </a:solidFill>
                 <a:latin typeface="Arial"/>
               </a:rPr>
-              <a:t>Führungsstil-Entscheidung von Marlies</a:t>
+              <a:t>Tabelle nach Hersey &amp; Blanchard (1996, S. 189–213)</a:t>
             </a:r>
           </a:p>
           <a:p>
@@ -6771,7 +8288,7 @@
                 </a:solidFill>
                 <a:latin typeface="Arial"/>
               </a:rPr>
-              <a:t>Für Jonas (Aufgabe: eigenständige Kreditunterlagenprüfung):</a:t>
+              <a:t>Hinweis zu D2 – das kritischste Stadium</a:t>
             </a:r>
           </a:p>
           <a:p>
@@ -6790,7 +8307,7 @@
                 </a:solidFill>
                 <a:latin typeface="Arial"/>
               </a:rPr>
-              <a:t>Reifegrad: D1 – Jonas will und ist motiviert (hohes Engagement), kann die Aufgabe aber noch nicht eigenständig sicher bearbeiten (geringes aufgabenbezogenes Können).</a:t>
+              <a:t>Tabelle nach Hersey &amp; Blanchard (1996, S. 200–208)</a:t>
             </a:r>
           </a:p>
           <a:p>
@@ -6809,11 +8326,11 @@
                 </a:solidFill>
                 <a:latin typeface="Arial"/>
               </a:rPr>
-              <a:t>Für Sigrid (Aufgabe: Ratingtool-Nutzung):</a:t>
-            </a:r>
-          </a:p>
-          <a:p>
-            <a:pPr>
+              <a:t>Brücke zur transformationalen Führung</a:t>
+            </a:r>
+          </a:p>
+          <a:p>
+            <a:pPr marL="190500" indent="-190500">
               <a:spcBef>
                 <a:spcPts val="400"/>
               </a:spcBef>
@@ -6822,51 +8339,13 @@
               </a:spcAft>
             </a:pPr>
             <a:r>
-              <a:rPr sz="1200">
+              <a:rPr sz="1300">
                 <a:solidFill>
                   <a:srgbClr val="3D5466"/>
                 </a:solidFill>
                 <a:latin typeface="Arial"/>
               </a:rPr>
-              <a:t>Fall-Fortführung: Was macht Marlies, wenn Sigrid das Tool trotzdem nicht nutzt?</a:t>
-            </a:r>
-          </a:p>
-          <a:p>
-            <a:pPr>
-              <a:spcBef>
-                <a:spcPts val="400"/>
-              </a:spcBef>
-              <a:spcAft>
-                <a:spcPts val="200"/>
-              </a:spcAft>
-            </a:pPr>
-            <a:r>
-              <a:rPr sz="1200">
-                <a:solidFill>
-                  <a:srgbClr val="3D5466"/>
-                </a:solidFill>
-                <a:latin typeface="Arial"/>
-              </a:rPr>
-              <a:t>Das ist keine Kommunikationsfrage mehr. Es ist eine Führungsfrage.</a:t>
-            </a:r>
-          </a:p>
-          <a:p>
-            <a:pPr>
-              <a:spcBef>
-                <a:spcPts val="400"/>
-              </a:spcBef>
-              <a:spcAft>
-                <a:spcPts val="200"/>
-              </a:spcAft>
-            </a:pPr>
-            <a:r>
-              <a:rPr sz="1200">
-                <a:solidFill>
-                  <a:srgbClr val="3D5466"/>
-                </a:solidFill>
-                <a:latin typeface="Arial"/>
-              </a:rPr>
-              <a:t>Warum das Gespräch jetzt anders ist</a:t>
+              <a:t>▸  I1 – Idealized Influence (Vorbildwirkung): Die Führungskraft verkörpert Werte, schafft Identifikation</a:t>
             </a:r>
           </a:p>
         </p:txBody>
@@ -6982,7 +8461,7 @@
             <a:avLst/>
           </a:prstGeom>
           <a:solidFill>
-            <a:srgbClr val="EDEDF3"/>
+            <a:srgbClr val="FFFFFF"/>
           </a:solidFill>
           <a:ln>
             <a:noFill/>
@@ -7083,51 +8562,43 @@
                 </a:solidFill>
                 <a:latin typeface="Consolas"/>
               </a:rPr>
-              <a:t>TL02  ·  INHALT</a:t>
-            </a:r>
-          </a:p>
-        </p:txBody>
-      </p:sp>
-      <p:sp>
-        <p:nvSpPr>
-          <p:cNvPr id="5" name="Rectangle 4"/>
-          <p:cNvSpPr/>
-          <p:nvPr/>
-        </p:nvSpPr>
-        <p:spPr>
-          <a:xfrm>
-            <a:off x="0" y="1234440"/>
-            <a:ext cx="12188952" cy="12700"/>
-          </a:xfrm>
-          <a:prstGeom prst="rect">
-            <a:avLst/>
-          </a:prstGeom>
-          <a:solidFill>
-            <a:srgbClr val="D8DFE4"/>
-          </a:solidFill>
-          <a:ln>
-            <a:noFill/>
-          </a:ln>
-        </p:spPr>
-        <p:style>
-          <a:lnRef idx="1">
-            <a:schemeClr val="accent1"/>
-          </a:lnRef>
-          <a:fillRef idx="3">
-            <a:schemeClr val="accent1"/>
-          </a:fillRef>
-          <a:effectRef idx="2">
-            <a:schemeClr val="accent1"/>
-          </a:effectRef>
-          <a:fontRef idx="minor">
-            <a:schemeClr val="lt1"/>
-          </a:fontRef>
-        </p:style>
-        <p:txBody>
-          <a:bodyPr rtlCol="0" anchor="ctr"/>
-          <a:lstStyle/>
-          <a:p>
-            <a:pPr algn="ctr"/>
+              <a:t>TL02  ·  SCHAUBILD</a:t>
+            </a:r>
+          </a:p>
+        </p:txBody>
+      </p:sp>
+      <p:sp>
+        <p:nvSpPr>
+          <p:cNvPr id="5" name="TextBox 4"/>
+          <p:cNvSpPr txBox="1"/>
+          <p:nvPr/>
+        </p:nvSpPr>
+        <p:spPr>
+          <a:xfrm>
+            <a:off x="685800" y="502920"/>
+            <a:ext cx="10817352" cy="594360"/>
+          </a:xfrm>
+          <a:prstGeom prst="rect">
+            <a:avLst/>
+          </a:prstGeom>
+          <a:noFill/>
+        </p:spPr>
+        <p:txBody>
+          <a:bodyPr wrap="square">
+            <a:spAutoFit/>
+          </a:bodyPr>
+          <a:lstStyle/>
+          <a:p>
+            <a:pPr algn="l"/>
+            <a:r>
+              <a:rPr sz="2000" b="1" i="0">
+                <a:solidFill>
+                  <a:srgbClr val="1F2C56"/>
+                </a:solidFill>
+                <a:latin typeface="Arial"/>
+              </a:rPr>
+              <a:t>Situatives Führen nach Hersey und Blanchard: Die vier Führungsstile S1</a:t>
+            </a:r>
           </a:p>
         </p:txBody>
       </p:sp>
@@ -7139,8 +8610,8 @@
         </p:nvSpPr>
         <p:spPr>
           <a:xfrm>
-            <a:off x="685800" y="502920"/>
-            <a:ext cx="36576" cy="658368"/>
+            <a:off x="685800" y="1143000"/>
+            <a:ext cx="10817352" cy="25400"/>
           </a:xfrm>
           <a:prstGeom prst="rect">
             <a:avLst/>
@@ -7174,238 +8645,33 @@
           </a:p>
         </p:txBody>
       </p:sp>
-      <p:sp>
-        <p:nvSpPr>
-          <p:cNvPr id="7" name="TextBox 6"/>
-          <p:cNvSpPr txBox="1"/>
-          <p:nvPr/>
-        </p:nvSpPr>
-        <p:spPr>
-          <a:xfrm>
-            <a:off x="813816" y="502920"/>
-            <a:ext cx="10634472" cy="685800"/>
-          </a:xfrm>
-          <a:prstGeom prst="rect">
-            <a:avLst/>
-          </a:prstGeom>
-          <a:noFill/>
-        </p:spPr>
-        <p:txBody>
-          <a:bodyPr wrap="square">
-            <a:spAutoFit/>
-          </a:bodyPr>
-          <a:lstStyle/>
-          <a:p>
-            <a:pPr algn="l"/>
-            <a:r>
-              <a:rPr sz="2400" b="1" i="0">
-                <a:solidFill>
-                  <a:srgbClr val="1F2C56"/>
-                </a:solidFill>
-                <a:latin typeface="Arial"/>
-              </a:rPr>
-              <a:t>Kollegiale Fallberatung: Wenn die Vereinbarung nicht eingehalten wird</a:t>
-            </a:r>
-          </a:p>
-        </p:txBody>
-      </p:sp>
-      <p:sp>
-        <p:nvSpPr>
-          <p:cNvPr id="8" name="TextBox 7"/>
-          <p:cNvSpPr txBox="1"/>
-          <p:nvPr/>
-        </p:nvSpPr>
-        <p:spPr>
-          <a:xfrm>
-            <a:off x="685800" y="1417320"/>
-            <a:ext cx="10817352" cy="4892040"/>
-          </a:xfrm>
-          <a:prstGeom prst="rect">
-            <a:avLst/>
-          </a:prstGeom>
-          <a:noFill/>
-        </p:spPr>
-        <p:txBody>
-          <a:bodyPr wrap="square">
-            <a:spAutoFit/>
-          </a:bodyPr>
-          <a:lstStyle/>
-          <a:p>
-            <a:pPr>
-              <a:spcBef>
-                <a:spcPts val="400"/>
-              </a:spcBef>
-              <a:spcAft>
-                <a:spcPts val="200"/>
-              </a:spcAft>
-            </a:pPr>
-            <a:r>
-              <a:rPr sz="1200">
-                <a:solidFill>
-                  <a:srgbClr val="3D5466"/>
-                </a:solidFill>
-                <a:latin typeface="Arial"/>
-              </a:rPr>
-              <a:t>Format: Kollegiale Fallberatung (kein Rollenspiel) in Dreiergruppen, ca. 20 Minuten</a:t>
-            </a:r>
-          </a:p>
-          <a:p>
-            <a:pPr>
-              <a:spcBef>
-                <a:spcPts val="400"/>
-              </a:spcBef>
-              <a:spcAft>
-                <a:spcPts val="200"/>
-              </a:spcAft>
-            </a:pPr>
-            <a:r>
-              <a:rPr sz="1200">
-                <a:solidFill>
-                  <a:srgbClr val="3D5466"/>
-                </a:solidFill>
-                <a:latin typeface="Arial"/>
-              </a:rPr>
-              <a:t>Aufgabe: Bereiten Sie für einen der folgenden Ausgangsfälle ein Konsequenzgespräch vor. Wählen Sie den Fall, der Ihrer eigenen Führungssituation am nächsten ist.</a:t>
-            </a:r>
-          </a:p>
-          <a:p>
-            <a:pPr>
-              <a:spcBef>
-                <a:spcPts val="400"/>
-              </a:spcBef>
-              <a:spcAft>
-                <a:spcPts val="200"/>
-              </a:spcAft>
-            </a:pPr>
-            <a:r>
-              <a:rPr sz="1200">
-                <a:solidFill>
-                  <a:srgbClr val="3D5466"/>
-                </a:solidFill>
-                <a:latin typeface="Arial"/>
-              </a:rPr>
-              <a:t>Ausgangsfall A (orientiert am Sigrid-Fall):</a:t>
-            </a:r>
-          </a:p>
-          <a:p>
-            <a:pPr>
-              <a:spcBef>
-                <a:spcPts val="400"/>
-              </a:spcBef>
-              <a:spcAft>
-                <a:spcPts val="200"/>
-              </a:spcAft>
-            </a:pPr>
-            <a:r>
-              <a:rPr sz="1200">
-                <a:solidFill>
-                  <a:srgbClr val="3D5466"/>
-                </a:solidFill>
-                <a:latin typeface="Arial"/>
-              </a:rPr>
-              <a:t>Ausgangsfall B (eigener Fall):</a:t>
-            </a:r>
-          </a:p>
-          <a:p>
-            <a:pPr>
-              <a:spcBef>
-                <a:spcPts val="400"/>
-              </a:spcBef>
-              <a:spcAft>
-                <a:spcPts val="200"/>
-              </a:spcAft>
-            </a:pPr>
-            <a:r>
-              <a:rPr sz="1200">
-                <a:solidFill>
-                  <a:srgbClr val="3D5466"/>
-                </a:solidFill>
-                <a:latin typeface="Arial"/>
-              </a:rPr>
-              <a:t>Sie bringen eine eigene Führungssituation aus Ihrem Team mit, in der eine Vereinbarung nicht eingehalten wurde.</a:t>
-            </a:r>
-          </a:p>
-          <a:p>
-            <a:pPr>
-              <a:spcBef>
-                <a:spcPts val="400"/>
-              </a:spcBef>
-              <a:spcAft>
-                <a:spcPts val="200"/>
-              </a:spcAft>
-            </a:pPr>
-            <a:r>
-              <a:rPr sz="1200">
-                <a:solidFill>
-                  <a:srgbClr val="3D5466"/>
-                </a:solidFill>
-                <a:latin typeface="Arial"/>
-              </a:rPr>
-              <a:t>Schritt 1 – Sachverhalt klären (5 Min., Einzelarbeit):</a:t>
-            </a:r>
-          </a:p>
-          <a:p>
-            <a:pPr>
-              <a:spcBef>
-                <a:spcPts val="400"/>
-              </a:spcBef>
-              <a:spcAft>
-                <a:spcPts val="200"/>
-              </a:spcAft>
-            </a:pPr>
-            <a:r>
-              <a:rPr sz="1200">
-                <a:solidFill>
-                  <a:srgbClr val="3D5466"/>
-                </a:solidFill>
-                <a:latin typeface="Arial"/>
-              </a:rPr>
-              <a:t>Schritt 2 – Gesprächseinstieg formulieren (5 Min., Einzelarbeit):</a:t>
-            </a:r>
-          </a:p>
-          <a:p>
-            <a:pPr>
-              <a:spcBef>
-                <a:spcPts val="400"/>
-              </a:spcBef>
-              <a:spcAft>
-                <a:spcPts val="200"/>
-              </a:spcAft>
-            </a:pPr>
-            <a:r>
-              <a:rPr sz="1200">
-                <a:solidFill>
-                  <a:srgbClr val="3D5466"/>
-                </a:solidFill>
-                <a:latin typeface="Arial"/>
-              </a:rPr>
-              <a:t>Formulieren Sie Ihren Gesprächseinstieg in 2–3 Sätzen: sachlich, direkt, nicht anklagend.</a:t>
-            </a:r>
-          </a:p>
-          <a:p>
-            <a:pPr>
-              <a:spcBef>
-                <a:spcPts val="400"/>
-              </a:spcBef>
-              <a:spcAft>
-                <a:spcPts val="200"/>
-              </a:spcAft>
-            </a:pPr>
-            <a:r>
-              <a:rPr sz="1200">
-                <a:solidFill>
-                  <a:srgbClr val="3D5466"/>
-                </a:solidFill>
-                <a:latin typeface="Arial"/>
-              </a:rPr>
-              <a:t>Schritt 3 – Kollegiale Rückmeldung (10 Min., Dreiergruppe):</a:t>
-            </a:r>
-          </a:p>
-        </p:txBody>
-      </p:sp>
-      <p:sp>
-        <p:nvSpPr>
-          <p:cNvPr id="9" name="Rectangle 8"/>
+      <p:pic>
+        <p:nvPicPr>
+          <p:cNvPr id="7" name="Picture 6" descr="image.png"/>
+          <p:cNvPicPr>
+            <a:picLocks noChangeAspect="1"/>
+          </p:cNvPicPr>
+          <p:nvPr/>
+        </p:nvPicPr>
+        <p:blipFill>
+          <a:blip r:embed="rId2"/>
+          <a:stretch>
+            <a:fillRect/>
+          </a:stretch>
+        </p:blipFill>
+        <p:spPr>
+          <a:xfrm>
+            <a:off x="2877694" y="1325880"/>
+            <a:ext cx="6433563" cy="4937760"/>
+          </a:xfrm>
+          <a:prstGeom prst="rect">
+            <a:avLst/>
+          </a:prstGeom>
+        </p:spPr>
+      </p:pic>
+      <p:sp>
+        <p:nvSpPr>
+          <p:cNvPr id="8" name="Rectangle 7"/>
           <p:cNvSpPr/>
           <p:nvPr/>
         </p:nvSpPr>
@@ -7448,7 +8714,7 @@
       </p:sp>
       <p:sp>
         <p:nvSpPr>
-          <p:cNvPr id="10" name="TextBox 9"/>
+          <p:cNvPr id="9" name="TextBox 8"/>
           <p:cNvSpPr txBox="1"/>
           <p:nvPr/>
         </p:nvSpPr>
@@ -7477,6 +8743,41 @@
                 <a:latin typeface="Consolas"/>
               </a:rPr>
               <a:t>FKB Campus  ·  TL02</a:t>
+            </a:r>
+          </a:p>
+        </p:txBody>
+      </p:sp>
+      <p:sp>
+        <p:nvSpPr>
+          <p:cNvPr id="10" name="TextBox 9"/>
+          <p:cNvSpPr txBox="1"/>
+          <p:nvPr/>
+        </p:nvSpPr>
+        <p:spPr>
+          <a:xfrm>
+            <a:off x="7176211" y="6583680"/>
+            <a:ext cx="4326940" cy="256032"/>
+          </a:xfrm>
+          <a:prstGeom prst="rect">
+            <a:avLst/>
+          </a:prstGeom>
+          <a:noFill/>
+        </p:spPr>
+        <p:txBody>
+          <a:bodyPr wrap="none">
+            <a:spAutoFit/>
+          </a:bodyPr>
+          <a:lstStyle/>
+          <a:p>
+            <a:pPr algn="r"/>
+            <a:r>
+              <a:rPr sz="700">
+                <a:solidFill>
+                  <a:srgbClr val="A0B4D2"/>
+                </a:solidFill>
+                <a:latin typeface="Consolas"/>
+              </a:rPr>
+              <a:t>Schaubild</a:t>
             </a:r>
           </a:p>
         </p:txBody>
@@ -7615,7 +8916,7 @@
                 </a:solidFill>
                 <a:latin typeface="Consolas"/>
               </a:rPr>
-              <a:t>TL02  ·  ARBEITSBLATT</a:t>
+              <a:t>TL02  ·  INHALT</a:t>
             </a:r>
           </a:p>
         </p:txBody>
@@ -7736,7 +9037,7 @@
                 </a:solidFill>
                 <a:latin typeface="Arial"/>
               </a:rPr>
-              <a:t>Selbstreflexion: Mein Standard-Führungsstil</a:t>
+              <a:t>Praxisfall: Zwei Berater, ein Teamleiter, zwei Führungsstile</a:t>
             </a:r>
           </a:p>
         </p:txBody>
@@ -7749,8 +9050,8 @@
         </p:nvSpPr>
         <p:spPr>
           <a:xfrm>
-            <a:off x="685800" y="1554480"/>
-            <a:ext cx="10817352" cy="3840480"/>
+            <a:off x="685800" y="1417320"/>
+            <a:ext cx="10817352" cy="4892040"/>
           </a:xfrm>
           <a:prstGeom prst="rect">
             <a:avLst/>
@@ -7762,6 +9063,63 @@
             <a:spAutoFit/>
           </a:bodyPr>
           <a:lstStyle/>
+          <a:p>
+            <a:pPr>
+              <a:spcBef>
+                <a:spcPts val="400"/>
+              </a:spcBef>
+              <a:spcAft>
+                <a:spcPts val="200"/>
+              </a:spcAft>
+            </a:pPr>
+            <a:r>
+              <a:rPr sz="1200">
+                <a:solidFill>
+                  <a:srgbClr val="3D5466"/>
+                </a:solidFill>
+                <a:latin typeface="Arial"/>
+              </a:rPr>
+              <a:t>Ausgangslage</a:t>
+            </a:r>
+          </a:p>
+          <a:p>
+            <a:pPr>
+              <a:spcBef>
+                <a:spcPts val="400"/>
+              </a:spcBef>
+              <a:spcAft>
+                <a:spcPts val="200"/>
+              </a:spcAft>
+            </a:pPr>
+            <a:r>
+              <a:rPr sz="1200">
+                <a:solidFill>
+                  <a:srgbClr val="3D5466"/>
+                </a:solidFill>
+                <a:latin typeface="Arial"/>
+              </a:rPr>
+              <a:t>Die Führungssituation</a:t>
+            </a:r>
+          </a:p>
+          <a:p>
+            <a:pPr>
+              <a:spcBef>
+                <a:spcPts val="400"/>
+              </a:spcBef>
+              <a:spcAft>
+                <a:spcPts val="200"/>
+              </a:spcAft>
+            </a:pPr>
+            <a:r>
+              <a:rPr sz="1200">
+                <a:solidFill>
+                  <a:srgbClr val="3D5466"/>
+                </a:solidFill>
+                <a:latin typeface="Arial"/>
+              </a:rPr>
+              <a:t>Marlies steht vor zwei gleichzeitigen Führungsaufgaben:</a:t>
+            </a:r>
+          </a:p>
           <a:p>
             <a:pPr marL="190500" indent="-190500">
               <a:spcBef>
@@ -7772,13 +9130,13 @@
               </a:spcAft>
             </a:pPr>
             <a:r>
-              <a:rPr sz="1400">
+              <a:rPr sz="1300">
                 <a:solidFill>
                   <a:srgbClr val="3D5466"/>
                 </a:solidFill>
                 <a:latin typeface="Arial"/>
               </a:rPr>
-              <a:t>▸  Nehmen Sie sich 5–7 Minuten und beantworten Sie die folgenden Fragen für sich – keine richtigen oder falschen Antworten, kein Test.</a:t>
+              <a:t>▸  Jonas soll die erste eigenständige Kreditunterlagenprüfung für einen mittelständischen Kunden (Umsatz ca. 12 Mio. EUR, Jahresabschluss vorliegend) vorbereiten – eine Aufgabe, die er strukturiert angehen kann, bei der er aber noch fachliche Unterstützung braucht.</a:t>
             </a:r>
           </a:p>
           <a:p>
@@ -7791,17 +9149,17 @@
               </a:spcAft>
             </a:pPr>
             <a:r>
-              <a:rPr sz="1400">
+              <a:rPr sz="1300">
                 <a:solidFill>
                   <a:srgbClr val="3D5466"/>
                 </a:solidFill>
                 <a:latin typeface="Arial"/>
               </a:rPr>
-              <a:t>▸  Leitfragen:</a:t>
-            </a:r>
-          </a:p>
-          <a:p>
-            <a:pPr marL="190500" indent="-190500">
+              <a:t>▸  Sigrid soll das neue Ratingtool bis Ende des Quartals für alle ihre Kreditfälle routinemäßig nutzen. Die Ablehnung gefährdet die Datenkonsistenz im Team und verstößt gegen die interne Vorgabe zur Nutzung des Bewertungssystems gem. § 18 KWG-Dokumentationsstandard.</a:t>
+            </a:r>
+          </a:p>
+          <a:p>
+            <a:pPr>
               <a:spcBef>
                 <a:spcPts val="400"/>
               </a:spcBef>
@@ -7810,17 +9168,17 @@
               </a:spcAft>
             </a:pPr>
             <a:r>
-              <a:rPr sz="1400">
+              <a:rPr sz="1200">
                 <a:solidFill>
                   <a:srgbClr val="3D5466"/>
                 </a:solidFill>
                 <a:latin typeface="Arial"/>
               </a:rPr>
-              <a:t>▸  Welchen Führungsstil setze ich in meinem Alltag am häufigsten ein? (Dirigieren / Coachen / Sekundieren / Delegieren)</a:t>
-            </a:r>
-          </a:p>
-          <a:p>
-            <a:pPr marL="190500" indent="-190500">
+              <a:t>Führungsstil-Entscheidung von Marlies</a:t>
+            </a:r>
+          </a:p>
+          <a:p>
+            <a:pPr>
               <a:spcBef>
                 <a:spcPts val="400"/>
               </a:spcBef>
@@ -7829,17 +9187,17 @@
               </a:spcAft>
             </a:pPr>
             <a:r>
-              <a:rPr sz="1400">
+              <a:rPr sz="1200">
                 <a:solidFill>
                   <a:srgbClr val="3D5466"/>
                 </a:solidFill>
                 <a:latin typeface="Arial"/>
               </a:rPr>
-              <a:t>▸  Bei welchem Mitarbeitertyp fühle ich mich als Führungskraft am sichersten / wirksamsten?</a:t>
-            </a:r>
-          </a:p>
-          <a:p>
-            <a:pPr marL="190500" indent="-190500">
+              <a:t>Für Jonas (Aufgabe: eigenständige Kreditunterlagenprüfung):</a:t>
+            </a:r>
+          </a:p>
+          <a:p>
+            <a:pPr>
               <a:spcBef>
                 <a:spcPts val="400"/>
               </a:spcBef>
@@ -7848,13 +9206,89 @@
               </a:spcAft>
             </a:pPr>
             <a:r>
-              <a:rPr sz="1400">
+              <a:rPr sz="1200">
                 <a:solidFill>
                   <a:srgbClr val="3D5466"/>
                 </a:solidFill>
                 <a:latin typeface="Arial"/>
               </a:rPr>
-              <a:t>▸  Gibt es Stile, die mir schwerfallen oder die ich selten bewusst einsetze? Welche?</a:t>
+              <a:t>Reifegrad: D1 – Jonas will und ist motiviert (hohes Engagement), kann die Aufgabe aber noch nicht eigenständig sicher bearbeiten (geringes aufgabenbezogenes Können).</a:t>
+            </a:r>
+          </a:p>
+          <a:p>
+            <a:pPr>
+              <a:spcBef>
+                <a:spcPts val="400"/>
+              </a:spcBef>
+              <a:spcAft>
+                <a:spcPts val="200"/>
+              </a:spcAft>
+            </a:pPr>
+            <a:r>
+              <a:rPr sz="1200">
+                <a:solidFill>
+                  <a:srgbClr val="3D5466"/>
+                </a:solidFill>
+                <a:latin typeface="Arial"/>
+              </a:rPr>
+              <a:t>Für Sigrid (Aufgabe: Ratingtool-Nutzung):</a:t>
+            </a:r>
+          </a:p>
+          <a:p>
+            <a:pPr>
+              <a:spcBef>
+                <a:spcPts val="400"/>
+              </a:spcBef>
+              <a:spcAft>
+                <a:spcPts val="200"/>
+              </a:spcAft>
+            </a:pPr>
+            <a:r>
+              <a:rPr sz="1200">
+                <a:solidFill>
+                  <a:srgbClr val="3D5466"/>
+                </a:solidFill>
+                <a:latin typeface="Arial"/>
+              </a:rPr>
+              <a:t>Fall-Fortführung: Was macht Marlies, wenn Sigrid das Tool trotzdem nicht nutzt?</a:t>
+            </a:r>
+          </a:p>
+          <a:p>
+            <a:pPr>
+              <a:spcBef>
+                <a:spcPts val="400"/>
+              </a:spcBef>
+              <a:spcAft>
+                <a:spcPts val="200"/>
+              </a:spcAft>
+            </a:pPr>
+            <a:r>
+              <a:rPr sz="1200">
+                <a:solidFill>
+                  <a:srgbClr val="3D5466"/>
+                </a:solidFill>
+                <a:latin typeface="Arial"/>
+              </a:rPr>
+              <a:t>Das ist keine Kommunikationsfrage mehr. Es ist eine Führungsfrage.</a:t>
+            </a:r>
+          </a:p>
+          <a:p>
+            <a:pPr>
+              <a:spcBef>
+                <a:spcPts val="400"/>
+              </a:spcBef>
+              <a:spcAft>
+                <a:spcPts val="200"/>
+              </a:spcAft>
+            </a:pPr>
+            <a:r>
+              <a:rPr sz="1200">
+                <a:solidFill>
+                  <a:srgbClr val="3D5466"/>
+                </a:solidFill>
+                <a:latin typeface="Arial"/>
+              </a:rPr>
+              <a:t>Warum das Gespräch jetzt anders ist</a:t>
             </a:r>
           </a:p>
         </p:txBody>
@@ -7862,84 +9296,6 @@
       <p:sp>
         <p:nvSpPr>
           <p:cNvPr id="9" name="Rectangle 8"/>
-          <p:cNvSpPr/>
-          <p:nvPr/>
-        </p:nvSpPr>
-        <p:spPr>
-          <a:xfrm>
-            <a:off x="685800" y="5486400"/>
-            <a:ext cx="10817352" cy="640080"/>
-          </a:xfrm>
-          <a:prstGeom prst="rect">
-            <a:avLst/>
-          </a:prstGeom>
-          <a:solidFill>
-            <a:srgbClr val="1F2C56"/>
-          </a:solidFill>
-          <a:ln>
-            <a:noFill/>
-          </a:ln>
-        </p:spPr>
-        <p:style>
-          <a:lnRef idx="1">
-            <a:schemeClr val="accent1"/>
-          </a:lnRef>
-          <a:fillRef idx="3">
-            <a:schemeClr val="accent1"/>
-          </a:fillRef>
-          <a:effectRef idx="2">
-            <a:schemeClr val="accent1"/>
-          </a:effectRef>
-          <a:fontRef idx="minor">
-            <a:schemeClr val="lt1"/>
-          </a:fontRef>
-        </p:style>
-        <p:txBody>
-          <a:bodyPr rtlCol="0" anchor="ctr"/>
-          <a:lstStyle/>
-          <a:p>
-            <a:pPr algn="ctr"/>
-          </a:p>
-        </p:txBody>
-      </p:sp>
-      <p:sp>
-        <p:nvSpPr>
-          <p:cNvPr id="10" name="TextBox 9"/>
-          <p:cNvSpPr txBox="1"/>
-          <p:nvPr/>
-        </p:nvSpPr>
-        <p:spPr>
-          <a:xfrm>
-            <a:off x="868680" y="5596128"/>
-            <a:ext cx="10451592" cy="457200"/>
-          </a:xfrm>
-          <a:prstGeom prst="rect">
-            <a:avLst/>
-          </a:prstGeom>
-          <a:noFill/>
-        </p:spPr>
-        <p:txBody>
-          <a:bodyPr wrap="square">
-            <a:spAutoFit/>
-          </a:bodyPr>
-          <a:lstStyle/>
-          <a:p>
-            <a:pPr algn="l"/>
-            <a:r>
-              <a:rPr sz="1300" b="1" i="0">
-                <a:solidFill>
-                  <a:srgbClr val="FFFFFF"/>
-                </a:solidFill>
-                <a:latin typeface="Arial"/>
-              </a:rPr>
-              <a:t>→  Bearbeitung im Teilnehmer-Workbook (Arbeitsblatt mit Ausfüllfeldern)</a:t>
-            </a:r>
-          </a:p>
-        </p:txBody>
-      </p:sp>
-      <p:sp>
-        <p:nvSpPr>
-          <p:cNvPr id="11" name="Rectangle 10"/>
           <p:cNvSpPr/>
           <p:nvPr/>
         </p:nvSpPr>
@@ -7982,7 +9338,7 @@
       </p:sp>
       <p:sp>
         <p:nvSpPr>
-          <p:cNvPr id="12" name="TextBox 11"/>
+          <p:cNvPr id="10" name="TextBox 9"/>
           <p:cNvSpPr txBox="1"/>
           <p:nvPr/>
         </p:nvSpPr>
@@ -8270,7 +9626,7 @@
                 </a:solidFill>
                 <a:latin typeface="Arial"/>
               </a:rPr>
-              <a:t>Stil- und Merkkarte: Situatives Führen auf einen Blick</a:t>
+              <a:t>Kollegiale Fallberatung: Wenn die Vereinbarung nicht eingehalten wird</a:t>
             </a:r>
           </a:p>
         </p:txBody>
@@ -8312,7 +9668,7 @@
                 </a:solidFill>
                 <a:latin typeface="Arial"/>
               </a:rPr>
-              <a:t>Die vier Führungsstile nach Hersey &amp; Blanchard (1996)</a:t>
+              <a:t>Format: Kollegiale Fallberatung (kein Rollenspiel) in Dreiergruppen, ca. 20 Minuten</a:t>
             </a:r>
           </a:p>
           <a:p>
@@ -8331,102 +9687,7 @@
                 </a:solidFill>
                 <a:latin typeface="Arial"/>
               </a:rPr>
-              <a:t>Der Diagnosepfad:</a:t>
-            </a:r>
-          </a:p>
-          <a:p>
-            <a:pPr marL="190500" indent="-190500">
-              <a:spcBef>
-                <a:spcPts val="400"/>
-              </a:spcBef>
-              <a:spcAft>
-                <a:spcPts val="200"/>
-              </a:spcAft>
-            </a:pPr>
-            <a:r>
-              <a:rPr sz="1300">
-                <a:solidFill>
-                  <a:srgbClr val="3D5466"/>
-                </a:solidFill>
-                <a:latin typeface="Arial"/>
-              </a:rPr>
-              <a:t>▸  Aufgabe benennen – Reifegrad ist immer aufgabenbezogen, nicht personenbezogen</a:t>
-            </a:r>
-          </a:p>
-          <a:p>
-            <a:pPr marL="190500" indent="-190500">
-              <a:spcBef>
-                <a:spcPts val="400"/>
-              </a:spcBef>
-              <a:spcAft>
-                <a:spcPts val="200"/>
-              </a:spcAft>
-            </a:pPr>
-            <a:r>
-              <a:rPr sz="1300">
-                <a:solidFill>
-                  <a:srgbClr val="3D5466"/>
-                </a:solidFill>
-                <a:latin typeface="Arial"/>
-              </a:rPr>
-              <a:t>▸  Kompetenz einschätzen – Kann er/sie das? (Können, Wissen, Erfahrung für genau dies)</a:t>
-            </a:r>
-          </a:p>
-          <a:p>
-            <a:pPr marL="190500" indent="-190500">
-              <a:spcBef>
-                <a:spcPts val="400"/>
-              </a:spcBef>
-              <a:spcAft>
-                <a:spcPts val="200"/>
-              </a:spcAft>
-            </a:pPr>
-            <a:r>
-              <a:rPr sz="1300">
-                <a:solidFill>
-                  <a:srgbClr val="3D5466"/>
-                </a:solidFill>
-                <a:latin typeface="Arial"/>
-              </a:rPr>
-              <a:t>▸  Engagement einschätzen – Will er/sie das? (Motivation, Selbstvertrauen, Bereitschaft)</a:t>
-            </a:r>
-          </a:p>
-          <a:p>
-            <a:pPr marL="190500" indent="-190500">
-              <a:spcBef>
-                <a:spcPts val="400"/>
-              </a:spcBef>
-              <a:spcAft>
-                <a:spcPts val="200"/>
-              </a:spcAft>
-            </a:pPr>
-            <a:r>
-              <a:rPr sz="1300">
-                <a:solidFill>
-                  <a:srgbClr val="3D5466"/>
-                </a:solidFill>
-                <a:latin typeface="Arial"/>
-              </a:rPr>
-              <a:t>▸  Reifegrad bestimmen (D1–D4)</a:t>
-            </a:r>
-          </a:p>
-          <a:p>
-            <a:pPr marL="190500" indent="-190500">
-              <a:spcBef>
-                <a:spcPts val="400"/>
-              </a:spcBef>
-              <a:spcAft>
-                <a:spcPts val="200"/>
-              </a:spcAft>
-            </a:pPr>
-            <a:r>
-              <a:rPr sz="1300">
-                <a:solidFill>
-                  <a:srgbClr val="3D5466"/>
-                </a:solidFill>
-                <a:latin typeface="Arial"/>
-              </a:rPr>
-              <a:t>▸  Stil ableiten (S1–S4) und im Gespräch zeigen</a:t>
+              <a:t>Aufgabe: Bereiten Sie für einen der folgenden Ausgangsfälle ein Konsequenzgespräch vor. Wählen Sie den Fall, der Ihrer eigenen Führungssituation am nächsten ist.</a:t>
             </a:r>
           </a:p>
           <a:p>
@@ -8445,11 +9706,11 @@
                 </a:solidFill>
                 <a:latin typeface="Arial"/>
               </a:rPr>
-              <a:t>Warnsignale für Stil-Mismatch:</a:t>
-            </a:r>
-          </a:p>
-          <a:p>
-            <a:pPr marL="190500" indent="-190500">
+              <a:t>Ausgangsfall A (orientiert am Sigrid-Fall):</a:t>
+            </a:r>
+          </a:p>
+          <a:p>
+            <a:pPr>
               <a:spcBef>
                 <a:spcPts val="400"/>
               </a:spcBef>
@@ -8458,17 +9719,17 @@
               </a:spcAft>
             </a:pPr>
             <a:r>
-              <a:rPr sz="1300">
+              <a:rPr sz="1200">
                 <a:solidFill>
                   <a:srgbClr val="3D5466"/>
                 </a:solidFill>
                 <a:latin typeface="Arial"/>
               </a:rPr>
-              <a:t>▸  Engagierter Mitarbeiter wird zunehmend passiv → Überführungsgefahr (zu viel S1 bei steigendem Reifegrad)</a:t>
-            </a:r>
-          </a:p>
-          <a:p>
-            <a:pPr marL="190500" indent="-190500">
+              <a:t>Ausgangsfall B (eigener Fall):</a:t>
+            </a:r>
+          </a:p>
+          <a:p>
+            <a:pPr>
               <a:spcBef>
                 <a:spcPts val="400"/>
               </a:spcBef>
@@ -8477,17 +9738,17 @@
               </a:spcAft>
             </a:pPr>
             <a:r>
-              <a:rPr sz="1300">
+              <a:rPr sz="1200">
                 <a:solidFill>
                   <a:srgbClr val="3D5466"/>
                 </a:solidFill>
                 <a:latin typeface="Arial"/>
               </a:rPr>
-              <a:t>▸  Kompetenter Mitarbeiter macht Fehler, die er eigentlich nicht macht → möglicherweise S3 nötig statt S4 (Selbstvertrauen gesunken)</a:t>
-            </a:r>
-          </a:p>
-          <a:p>
-            <a:pPr marL="190500" indent="-190500">
+              <a:t>Sie bringen eine eigene Führungssituation aus Ihrem Team mit, in der eine Vereinbarung nicht eingehalten wurde.</a:t>
+            </a:r>
+          </a:p>
+          <a:p>
+            <a:pPr>
               <a:spcBef>
                 <a:spcPts val="400"/>
               </a:spcBef>
@@ -8496,17 +9757,17 @@
               </a:spcAft>
             </a:pPr>
             <a:r>
-              <a:rPr sz="1300">
+              <a:rPr sz="1200">
                 <a:solidFill>
                   <a:srgbClr val="3D5466"/>
                 </a:solidFill>
                 <a:latin typeface="Arial"/>
               </a:rPr>
-              <a:t>▸  Mitarbeiter fragt bei Kleinigkeiten ständig nach → Delegationslücke, S4 noch nicht eingesetzt</a:t>
-            </a:r>
-          </a:p>
-          <a:p>
-            <a:pPr marL="190500" indent="-190500">
+              <a:t>Schritt 1 – Sachverhalt klären (5 Min., Einzelarbeit):</a:t>
+            </a:r>
+          </a:p>
+          <a:p>
+            <a:pPr>
               <a:spcBef>
                 <a:spcPts val="400"/>
               </a:spcBef>
@@ -8515,13 +9776,51 @@
               </a:spcAft>
             </a:pPr>
             <a:r>
-              <a:rPr sz="1300">
+              <a:rPr sz="1200">
                 <a:solidFill>
                   <a:srgbClr val="3D5466"/>
                 </a:solidFill>
                 <a:latin typeface="Arial"/>
               </a:rPr>
-              <a:t>▸  Motivation bricht nach neuer Aufgabe ein → Reifegrad ist aufgabenspezifisch auf D1/D2 zurückgefallen → zurück zu S1/S2</a:t>
+              <a:t>Schritt 2 – Gesprächseinstieg formulieren (5 Min., Einzelarbeit):</a:t>
+            </a:r>
+          </a:p>
+          <a:p>
+            <a:pPr>
+              <a:spcBef>
+                <a:spcPts val="400"/>
+              </a:spcBef>
+              <a:spcAft>
+                <a:spcPts val="200"/>
+              </a:spcAft>
+            </a:pPr>
+            <a:r>
+              <a:rPr sz="1200">
+                <a:solidFill>
+                  <a:srgbClr val="3D5466"/>
+                </a:solidFill>
+                <a:latin typeface="Arial"/>
+              </a:rPr>
+              <a:t>Formulieren Sie Ihren Gesprächseinstieg in 2–3 Sätzen: sachlich, direkt, nicht anklagend.</a:t>
+            </a:r>
+          </a:p>
+          <a:p>
+            <a:pPr>
+              <a:spcBef>
+                <a:spcPts val="400"/>
+              </a:spcBef>
+              <a:spcAft>
+                <a:spcPts val="200"/>
+              </a:spcAft>
+            </a:pPr>
+            <a:r>
+              <a:rPr sz="1200">
+                <a:solidFill>
+                  <a:srgbClr val="3D5466"/>
+                </a:solidFill>
+                <a:latin typeface="Arial"/>
+              </a:rPr>
+              <a:t>Schritt 3 – Kollegiale Rückmeldung (10 Min., Dreiergruppe):</a:t>
             </a:r>
           </a:p>
         </p:txBody>
@@ -8738,7 +10037,7 @@
                 </a:solidFill>
                 <a:latin typeface="Consolas"/>
               </a:rPr>
-              <a:t>TL02  ·  INHALT</a:t>
+              <a:t>TL02  ·  ARBEITSBLATT</a:t>
             </a:r>
           </a:p>
         </p:txBody>
@@ -8859,7 +10158,7 @@
                 </a:solidFill>
                 <a:latin typeface="Arial"/>
               </a:rPr>
-              <a:t>Checkliste: Führungsstil situativ anpassen</a:t>
+              <a:t>Selbstreflexion: Mein Standard-Führungsstil</a:t>
             </a:r>
           </a:p>
         </p:txBody>
@@ -8872,8 +10171,8 @@
         </p:nvSpPr>
         <p:spPr>
           <a:xfrm>
-            <a:off x="685800" y="1417320"/>
-            <a:ext cx="10817352" cy="4892040"/>
+            <a:off x="685800" y="1554480"/>
+            <a:ext cx="10817352" cy="3840480"/>
           </a:xfrm>
           <a:prstGeom prst="rect">
             <a:avLst/>
@@ -8885,25 +10184,6 @@
             <a:spAutoFit/>
           </a:bodyPr>
           <a:lstStyle/>
-          <a:p>
-            <a:pPr>
-              <a:spcBef>
-                <a:spcPts val="400"/>
-              </a:spcBef>
-              <a:spcAft>
-                <a:spcPts val="200"/>
-              </a:spcAft>
-            </a:pPr>
-            <a:r>
-              <a:rPr sz="1200">
-                <a:solidFill>
-                  <a:srgbClr val="3D5466"/>
-                </a:solidFill>
-                <a:latin typeface="Arial"/>
-              </a:rPr>
-              <a:t>Vor jedem Führungsgespräch (&lt; 2 Minuten)</a:t>
-            </a:r>
-          </a:p>
           <a:p>
             <a:pPr marL="190500" indent="-190500">
               <a:spcBef>
@@ -8914,13 +10194,13 @@
               </a:spcAft>
             </a:pPr>
             <a:r>
-              <a:rPr sz="1300">
+              <a:rPr sz="1400">
                 <a:solidFill>
                   <a:srgbClr val="3D5466"/>
                 </a:solidFill>
                 <a:latin typeface="Arial"/>
               </a:rPr>
-              <a:t>▸  [ ] Habe ich den Reifegrad des Mitarbeiters für diese konkrete Aufgabe eingeschätzt?</a:t>
+              <a:t>▸  Nehmen Sie sich 5–7 Minuten und beantworten Sie die folgenden Fragen für sich – keine richtigen oder falschen Antworten, kein Test.</a:t>
             </a:r>
           </a:p>
           <a:p>
@@ -8933,13 +10213,13 @@
               </a:spcAft>
             </a:pPr>
             <a:r>
-              <a:rPr sz="1300">
+              <a:rPr sz="1400">
                 <a:solidFill>
                   <a:srgbClr val="3D5466"/>
                 </a:solidFill>
                 <a:latin typeface="Arial"/>
               </a:rPr>
-              <a:t>▸  [ ] Habe ich bewusst einen Führungsstil gewählt – und nicht meinen Standard-Stil eingesetzt?</a:t>
+              <a:t>▸  Leitfragen:</a:t>
             </a:r>
           </a:p>
           <a:p>
@@ -8952,13 +10232,13 @@
               </a:spcAft>
             </a:pPr>
             <a:r>
-              <a:rPr sz="1300">
+              <a:rPr sz="1400">
                 <a:solidFill>
                   <a:srgbClr val="3D5466"/>
                 </a:solidFill>
                 <a:latin typeface="Arial"/>
               </a:rPr>
-              <a:t>▸  [ ] Kenne ich den Unterschied zwischen dem Können und dem Wollen des Mitarbeiters in dieser Situation?</a:t>
+              <a:t>▸  Welchen Führungsstil setze ich in meinem Alltag am häufigsten ein? (Dirigieren / Coachen / Sekundieren / Delegieren)</a:t>
             </a:r>
           </a:p>
           <a:p>
@@ -8971,32 +10251,13 @@
               </a:spcAft>
             </a:pPr>
             <a:r>
-              <a:rPr sz="1300">
+              <a:rPr sz="1400">
                 <a:solidFill>
                   <a:srgbClr val="3D5466"/>
                 </a:solidFill>
                 <a:latin typeface="Arial"/>
               </a:rPr>
-              <a:t>▸  [ ] Habe ich einen konkreten Einstiegssatz oder eine Frage vorbereitet, die meinen gewählten Stil zeigt?</a:t>
-            </a:r>
-          </a:p>
-          <a:p>
-            <a:pPr>
-              <a:spcBef>
-                <a:spcPts val="400"/>
-              </a:spcBef>
-              <a:spcAft>
-                <a:spcPts val="200"/>
-              </a:spcAft>
-            </a:pPr>
-            <a:r>
-              <a:rPr sz="1200">
-                <a:solidFill>
-                  <a:srgbClr val="3D5466"/>
-                </a:solidFill>
-                <a:latin typeface="Arial"/>
-              </a:rPr>
-              <a:t>Nach dem Gespräch (Kurzreflexion, &lt; 3 Minuten)</a:t>
+              <a:t>▸  Bei welchem Mitarbeitertyp fühle ich mich als Führungskraft am sichersten / wirksamsten?</a:t>
             </a:r>
           </a:p>
           <a:p>
@@ -9009,108 +10270,13 @@
               </a:spcAft>
             </a:pPr>
             <a:r>
-              <a:rPr sz="1300">
+              <a:rPr sz="1400">
                 <a:solidFill>
                   <a:srgbClr val="3D5466"/>
                 </a:solidFill>
                 <a:latin typeface="Arial"/>
               </a:rPr>
-              <a:t>▸  [ ] Hat mein Führungsverhalten zur Situation gepasst? Woran habe ich das gemerkt?</a:t>
-            </a:r>
-          </a:p>
-          <a:p>
-            <a:pPr marL="190500" indent="-190500">
-              <a:spcBef>
-                <a:spcPts val="400"/>
-              </a:spcBef>
-              <a:spcAft>
-                <a:spcPts val="200"/>
-              </a:spcAft>
-            </a:pPr>
-            <a:r>
-              <a:rPr sz="1300">
-                <a:solidFill>
-                  <a:srgbClr val="3D5466"/>
-                </a:solidFill>
-                <a:latin typeface="Arial"/>
-              </a:rPr>
-              <a:t>▸  [ ] Hat der Mitarbeiter so reagiert, wie ich es erwartet habe? Was hat mich überrascht?</a:t>
-            </a:r>
-          </a:p>
-          <a:p>
-            <a:pPr marL="190500" indent="-190500">
-              <a:spcBef>
-                <a:spcPts val="400"/>
-              </a:spcBef>
-              <a:spcAft>
-                <a:spcPts val="200"/>
-              </a:spcAft>
-            </a:pPr>
-            <a:r>
-              <a:rPr sz="1300">
-                <a:solidFill>
-                  <a:srgbClr val="3D5466"/>
-                </a:solidFill>
-                <a:latin typeface="Arial"/>
-              </a:rPr>
-              <a:t>▸  [ ] Müsste ich beim nächsten Gespräch den Stil anpassen?</a:t>
-            </a:r>
-          </a:p>
-          <a:p>
-            <a:pPr>
-              <a:spcBef>
-                <a:spcPts val="400"/>
-              </a:spcBef>
-              <a:spcAft>
-                <a:spcPts val="200"/>
-              </a:spcAft>
-            </a:pPr>
-            <a:r>
-              <a:rPr sz="1200">
-                <a:solidFill>
-                  <a:srgbClr val="3D5466"/>
-                </a:solidFill>
-                <a:latin typeface="Arial"/>
-              </a:rPr>
-              <a:t>Im Team-Rhythmus (monatlich)</a:t>
-            </a:r>
-          </a:p>
-          <a:p>
-            <a:pPr marL="190500" indent="-190500">
-              <a:spcBef>
-                <a:spcPts val="400"/>
-              </a:spcBef>
-              <a:spcAft>
-                <a:spcPts val="200"/>
-              </a:spcAft>
-            </a:pPr>
-            <a:r>
-              <a:rPr sz="1300">
-                <a:solidFill>
-                  <a:srgbClr val="3D5466"/>
-                </a:solidFill>
-                <a:latin typeface="Arial"/>
-              </a:rPr>
-              <a:t>▸  [ ] Bei welchem Mitarbeiter hat sich der Reifegrad in den letzten Wochen verändert?</a:t>
-            </a:r>
-          </a:p>
-          <a:p>
-            <a:pPr marL="190500" indent="-190500">
-              <a:spcBef>
-                <a:spcPts val="400"/>
-              </a:spcBef>
-              <a:spcAft>
-                <a:spcPts val="200"/>
-              </a:spcAft>
-            </a:pPr>
-            <a:r>
-              <a:rPr sz="1300">
-                <a:solidFill>
-                  <a:srgbClr val="3D5466"/>
-                </a:solidFill>
-                <a:latin typeface="Arial"/>
-              </a:rPr>
-              <a:t>▸  [ ] Habe ich meinen Führungsstil entsprechend angepasst – oder führe ich ihn/sie noch wie vor sechs Monaten?</a:t>
+              <a:t>▸  Gibt es Stile, die mir schwerfallen oder die ich selten bewusst einsetze? Welche?</a:t>
             </a:r>
           </a:p>
         </p:txBody>
@@ -9118,6 +10284,84 @@
       <p:sp>
         <p:nvSpPr>
           <p:cNvPr id="9" name="Rectangle 8"/>
+          <p:cNvSpPr/>
+          <p:nvPr/>
+        </p:nvSpPr>
+        <p:spPr>
+          <a:xfrm>
+            <a:off x="685800" y="5486400"/>
+            <a:ext cx="10817352" cy="640080"/>
+          </a:xfrm>
+          <a:prstGeom prst="rect">
+            <a:avLst/>
+          </a:prstGeom>
+          <a:solidFill>
+            <a:srgbClr val="1F2C56"/>
+          </a:solidFill>
+          <a:ln>
+            <a:noFill/>
+          </a:ln>
+        </p:spPr>
+        <p:style>
+          <a:lnRef idx="1">
+            <a:schemeClr val="accent1"/>
+          </a:lnRef>
+          <a:fillRef idx="3">
+            <a:schemeClr val="accent1"/>
+          </a:fillRef>
+          <a:effectRef idx="2">
+            <a:schemeClr val="accent1"/>
+          </a:effectRef>
+          <a:fontRef idx="minor">
+            <a:schemeClr val="lt1"/>
+          </a:fontRef>
+        </p:style>
+        <p:txBody>
+          <a:bodyPr rtlCol="0" anchor="ctr"/>
+          <a:lstStyle/>
+          <a:p>
+            <a:pPr algn="ctr"/>
+          </a:p>
+        </p:txBody>
+      </p:sp>
+      <p:sp>
+        <p:nvSpPr>
+          <p:cNvPr id="10" name="TextBox 9"/>
+          <p:cNvSpPr txBox="1"/>
+          <p:nvPr/>
+        </p:nvSpPr>
+        <p:spPr>
+          <a:xfrm>
+            <a:off x="868680" y="5596128"/>
+            <a:ext cx="10451592" cy="457200"/>
+          </a:xfrm>
+          <a:prstGeom prst="rect">
+            <a:avLst/>
+          </a:prstGeom>
+          <a:noFill/>
+        </p:spPr>
+        <p:txBody>
+          <a:bodyPr wrap="square">
+            <a:spAutoFit/>
+          </a:bodyPr>
+          <a:lstStyle/>
+          <a:p>
+            <a:pPr algn="l"/>
+            <a:r>
+              <a:rPr sz="1300" b="1" i="0">
+                <a:solidFill>
+                  <a:srgbClr val="FFFFFF"/>
+                </a:solidFill>
+                <a:latin typeface="Arial"/>
+              </a:rPr>
+              <a:t>→  Bearbeitung im Teilnehmer-Workbook (Arbeitsblatt mit Ausfüllfeldern)</a:t>
+            </a:r>
+          </a:p>
+        </p:txBody>
+      </p:sp>
+      <p:sp>
+        <p:nvSpPr>
+          <p:cNvPr id="11" name="Rectangle 10"/>
           <p:cNvSpPr/>
           <p:nvPr/>
         </p:nvSpPr>
@@ -9160,7 +10404,7 @@
       </p:sp>
       <p:sp>
         <p:nvSpPr>
-          <p:cNvPr id="10" name="TextBox 9"/>
+          <p:cNvPr id="12" name="TextBox 11"/>
           <p:cNvSpPr txBox="1"/>
           <p:nvPr/>
         </p:nvSpPr>

</xml_diff>